<commit_message>
System Design vi: sd-14-016 and sd-14-018 decks list every glossary term on the last slide
Co-Authored-By: Claude Sonnet 5.5 <noreply@anthropic.com>
Claude-Session: https://claude.ai/code/session_01WnjciXNJBLEd8jy3HrG49S
</commit_message>
<xml_diff>
--- a/system-design-101/vi/lessons/sd-14-016/slides/sd-14-016.pptx
+++ b/system-design-101/vi/lessons/sd-14-016/slides/sd-14-016.pptx
@@ -3435,93 +3435,18 @@
       </p:sp>
       <p:sp>
         <p:nvSpPr>
-          <p:cNvPr id="3" name="Text 1"/>
-          <p:cNvSpPr/>
-          <p:nvPr/>
-        </p:nvSpPr>
-        <p:spPr>
-          <a:xfrm>
-            <a:off x="914400" y="1333500"/>
-            <a:ext cx="16459200" cy="1190625"/>
-          </a:xfrm>
-          <a:prstGeom prst="rect">
-            <a:avLst/>
-          </a:prstGeom>
-          <a:noFill/>
-          <a:ln/>
-        </p:spPr>
-        <p:txBody>
-          <a:bodyPr wrap="square" lIns="0" tIns="64008" rIns="0" bIns="-64008" rtlCol="0" anchor="t"/>
-          <a:lstStyle/>
-          <a:p>
-            <a:pPr algn="l" indent="0" marL="0">
-              <a:lnSpc>
-                <a:spcPts val="7488"/>
-              </a:lnSpc>
-              <a:buNone/>
-            </a:pPr>
-            <a:r>
-              <a:rPr lang="en-US" sz="7200" dirty="0" spc="-55" kern="0">
-                <a:solidFill>
-                  <a:srgbClr val="F3EEE3"/>
-                </a:solidFill>
-                <a:latin typeface="Bricolage Grotesque ExtraBold" pitchFamily="34" charset="0"/>
-                <a:ea typeface="Bricolage Grotesque ExtraBold" pitchFamily="34" charset="-122"/>
-                <a:cs typeface="Bricolage Grotesque ExtraBold" pitchFamily="34" charset="-120"/>
-              </a:rPr>
-              <a:t>Từ</a:t>
-            </a:r>
-            <a:r>
-              <a:rPr lang="en-US" sz="7200" dirty="0" spc="-11" kern="0">
-                <a:solidFill>
-                  <a:srgbClr val="F3EEE3"/>
-                </a:solidFill>
-                <a:latin typeface="Bricolage Grotesque ExtraBold" pitchFamily="34" charset="0"/>
-                <a:ea typeface="Bricolage Grotesque ExtraBold" pitchFamily="34" charset="-122"/>
-                <a:cs typeface="Bricolage Grotesque ExtraBold" pitchFamily="34" charset="-120"/>
-              </a:rPr>
-              <a:t> khóa</a:t>
-            </a:r>
-            <a:r>
-              <a:rPr lang="en-US" sz="7200" dirty="0" spc="-14" kern="0">
-                <a:solidFill>
-                  <a:srgbClr val="F3EEE3"/>
-                </a:solidFill>
-                <a:latin typeface="Bricolage Grotesque ExtraBold" pitchFamily="34" charset="0"/>
-                <a:ea typeface="Bricolage Grotesque ExtraBold" pitchFamily="34" charset="-122"/>
-                <a:cs typeface="Bricolage Grotesque ExtraBold" pitchFamily="34" charset="-120"/>
-              </a:rPr>
-              <a:t> trong</a:t>
-            </a:r>
-            <a:r>
-              <a:rPr lang="en-US" sz="7200" dirty="0" spc="-7" kern="0">
-                <a:solidFill>
-                  <a:srgbClr val="F3EEE3"/>
-                </a:solidFill>
-                <a:latin typeface="Bricolage Grotesque ExtraBold" pitchFamily="34" charset="0"/>
-                <a:ea typeface="Bricolage Grotesque ExtraBold" pitchFamily="34" charset="-122"/>
-                <a:cs typeface="Bricolage Grotesque ExtraBold" pitchFamily="34" charset="-120"/>
-              </a:rPr>
-              <a:t> bài</a:t>
-            </a:r>
-            <a:endParaRPr lang="en-US" sz="7200" dirty="0"/>
-          </a:p>
-        </p:txBody>
-      </p:sp>
-      <p:sp>
-        <p:nvSpPr>
-          <p:cNvPr id="4" name="Shape 2"/>
-          <p:cNvSpPr/>
-          <p:nvPr/>
-        </p:nvSpPr>
-        <p:spPr>
-          <a:xfrm>
-            <a:off x="914400" y="2762250"/>
-            <a:ext cx="3886200" cy="2000250"/>
+          <p:cNvPr id="3" name="Shape 1"/>
+          <p:cNvSpPr/>
+          <p:nvPr/>
+        </p:nvSpPr>
+        <p:spPr>
+          <a:xfrm>
+            <a:off x="914400" y="1485900"/>
+            <a:ext cx="4000500" cy="1866900"/>
           </a:xfrm>
           <a:prstGeom prst="roundRect">
             <a:avLst>
-              <a:gd name="adj" fmla="val 11429"/>
+              <a:gd name="adj" fmla="val 11224"/>
             </a:avLst>
           </a:prstGeom>
           <a:solidFill>
@@ -3537,14 +3462,14 @@
       </p:sp>
       <p:sp>
         <p:nvSpPr>
-          <p:cNvPr id="5" name="Text 3"/>
-          <p:cNvSpPr/>
-          <p:nvPr/>
-        </p:nvSpPr>
-        <p:spPr>
-          <a:xfrm>
-            <a:off x="1143000" y="2933700"/>
-            <a:ext cx="3429000" cy="666750"/>
+          <p:cNvPr id="4" name="Text 2"/>
+          <p:cNvSpPr/>
+          <p:nvPr/>
+        </p:nvSpPr>
+        <p:spPr>
+          <a:xfrm>
+            <a:off x="1104900" y="1809750"/>
+            <a:ext cx="3619500" cy="438150"/>
           </a:xfrm>
           <a:prstGeom prst="rect">
             <a:avLst/>
@@ -3560,7 +3485,7 @@
               <a:buNone/>
             </a:pPr>
             <a:r>
-              <a:rPr lang="en-US" sz="3900" dirty="0" spc="-4" kern="0">
+              <a:rPr lang="en-US" sz="2550" dirty="0" spc="2" kern="0">
                 <a:solidFill>
                   <a:srgbClr val="7C93FF"/>
                 </a:solidFill>
@@ -3570,20 +3495,20 @@
               </a:rPr>
               <a:t>TLS</a:t>
             </a:r>
-            <a:endParaRPr lang="en-US" sz="3900" dirty="0"/>
+            <a:endParaRPr lang="en-US" sz="2550" dirty="0"/>
           </a:p>
         </p:txBody>
       </p:sp>
       <p:sp>
         <p:nvSpPr>
-          <p:cNvPr id="6" name="Text 4"/>
-          <p:cNvSpPr/>
-          <p:nvPr/>
-        </p:nvSpPr>
-        <p:spPr>
-          <a:xfrm>
-            <a:off x="1143000" y="3638550"/>
-            <a:ext cx="3486150" cy="304800"/>
+          <p:cNvPr id="5" name="Text 3"/>
+          <p:cNvSpPr/>
+          <p:nvPr/>
+        </p:nvSpPr>
+        <p:spPr>
+          <a:xfrm>
+            <a:off x="1104900" y="2286000"/>
+            <a:ext cx="3619500" cy="304800"/>
           </a:xfrm>
           <a:prstGeom prst="rect">
             <a:avLst/>
@@ -3637,14 +3562,14 @@
       </p:sp>
       <p:sp>
         <p:nvSpPr>
-          <p:cNvPr id="7" name="Text 5"/>
-          <p:cNvSpPr/>
-          <p:nvPr/>
-        </p:nvSpPr>
-        <p:spPr>
-          <a:xfrm>
-            <a:off x="1143000" y="4000500"/>
-            <a:ext cx="3429000" cy="666750"/>
+          <p:cNvPr id="6" name="Text 4"/>
+          <p:cNvSpPr/>
+          <p:nvPr/>
+        </p:nvSpPr>
+        <p:spPr>
+          <a:xfrm>
+            <a:off x="1104900" y="2647950"/>
+            <a:ext cx="3619500" cy="647700"/>
           </a:xfrm>
           <a:prstGeom prst="rect">
             <a:avLst/>
@@ -3653,17 +3578,17 @@
           <a:ln/>
         </p:spPr>
         <p:txBody>
-          <a:bodyPr wrap="square" lIns="0" tIns="9716" rIns="0" bIns="-9716" rtlCol="0" anchor="t"/>
+          <a:bodyPr wrap="square" lIns="0" tIns="8906" rIns="0" bIns="-8906" rtlCol="0" anchor="t"/>
           <a:lstStyle/>
           <a:p>
             <a:pPr algn="l" indent="0" marL="0">
               <a:lnSpc>
-                <a:spcPts val="2340"/>
+                <a:spcPts val="2145"/>
               </a:lnSpc>
               <a:buNone/>
             </a:pPr>
             <a:r>
-              <a:rPr lang="en-US" sz="1800" dirty="0" spc="-2" kern="0">
+              <a:rPr lang="en-US" sz="1650" dirty="0" spc="0" kern="0">
                 <a:solidFill>
                   <a:srgbClr val="D8D3C4"/>
                 </a:solidFill>
@@ -3674,7 +3599,7 @@
               <a:t>mã</a:t>
             </a:r>
             <a:r>
-              <a:rPr lang="en-US" sz="1800" dirty="0" spc="-1" kern="0">
+              <a:rPr lang="en-US" sz="1650" dirty="0" spc="-1" kern="0">
                 <a:solidFill>
                   <a:srgbClr val="D8D3C4"/>
                 </a:solidFill>
@@ -3685,7 +3610,7 @@
               <a:t> hóa</a:t>
             </a:r>
             <a:r>
-              <a:rPr lang="en-US" sz="1800" dirty="0" spc="0" kern="0">
+              <a:rPr lang="en-US" sz="1650" dirty="0" spc="1" kern="0">
                 <a:solidFill>
                   <a:srgbClr val="D8D3C4"/>
                 </a:solidFill>
@@ -3696,7 +3621,7 @@
               <a:t> dữ</a:t>
             </a:r>
             <a:r>
-              <a:rPr lang="en-US" sz="1800" dirty="0" spc="-2" kern="0">
+              <a:rPr lang="en-US" sz="1650" dirty="0" spc="0" kern="0">
                 <a:solidFill>
                   <a:srgbClr val="D8D3C4"/>
                 </a:solidFill>
@@ -3707,7 +3632,7 @@
               <a:t> liệu</a:t>
             </a:r>
             <a:r>
-              <a:rPr lang="en-US" sz="1800" dirty="0" spc="26" kern="0">
+              <a:rPr lang="en-US" sz="1650" dirty="0" spc="25" kern="0">
                 <a:solidFill>
                   <a:srgbClr val="D8D3C4"/>
                 </a:solidFill>
@@ -3718,7 +3643,7 @@
               <a:t> đi</a:t>
             </a:r>
             <a:r>
-              <a:rPr lang="en-US" sz="1800" dirty="0" spc="6" kern="0">
+              <a:rPr lang="en-US" sz="1650" dirty="0" spc="4" kern="0">
                 <a:solidFill>
                   <a:srgbClr val="D8D3C4"/>
                 </a:solidFill>
@@ -3729,7 +3654,7 @@
               <a:t> giữa</a:t>
             </a:r>
             <a:r>
-              <a:rPr lang="en-US" sz="1800" dirty="0" spc="1" kern="0">
+              <a:rPr lang="en-US" sz="1650" dirty="0" spc="0" kern="0">
                 <a:solidFill>
                   <a:srgbClr val="D8D3C4"/>
                 </a:solidFill>
@@ -3740,7 +3665,7 @@
               <a:t> hai</a:t>
             </a:r>
             <a:r>
-              <a:rPr lang="en-US" sz="1800" dirty="0" spc="-7" kern="0">
+              <a:rPr lang="en-US" sz="1650" dirty="0" spc="-5" kern="0">
                 <a:solidFill>
                   <a:srgbClr val="D8D3C4"/>
                 </a:solidFill>
@@ -3750,24 +3675,24 @@
               </a:rPr>
               <a:t> máy</a:t>
             </a:r>
-            <a:endParaRPr lang="en-US" sz="1800" dirty="0"/>
+            <a:endParaRPr lang="en-US" sz="1650" dirty="0"/>
           </a:p>
         </p:txBody>
       </p:sp>
       <p:sp>
         <p:nvSpPr>
-          <p:cNvPr id="8" name="Shape 6"/>
-          <p:cNvSpPr/>
-          <p:nvPr/>
-        </p:nvSpPr>
-        <p:spPr>
-          <a:xfrm>
-            <a:off x="5105400" y="2762250"/>
-            <a:ext cx="3886200" cy="2000250"/>
+          <p:cNvPr id="7" name="Shape 5"/>
+          <p:cNvSpPr/>
+          <p:nvPr/>
+        </p:nvSpPr>
+        <p:spPr>
+          <a:xfrm>
+            <a:off x="5067300" y="1485900"/>
+            <a:ext cx="4000500" cy="1866900"/>
           </a:xfrm>
           <a:prstGeom prst="roundRect">
             <a:avLst>
-              <a:gd name="adj" fmla="val 11429"/>
+              <a:gd name="adj" fmla="val 11224"/>
             </a:avLst>
           </a:prstGeom>
           <a:solidFill>
@@ -3783,14 +3708,14 @@
       </p:sp>
       <p:sp>
         <p:nvSpPr>
-          <p:cNvPr id="9" name="Text 7"/>
-          <p:cNvSpPr/>
-          <p:nvPr/>
-        </p:nvSpPr>
-        <p:spPr>
-          <a:xfrm>
-            <a:off x="5334000" y="2933700"/>
-            <a:ext cx="3429000" cy="666750"/>
+          <p:cNvPr id="8" name="Text 6"/>
+          <p:cNvSpPr/>
+          <p:nvPr/>
+        </p:nvSpPr>
+        <p:spPr>
+          <a:xfrm>
+            <a:off x="5257800" y="1809750"/>
+            <a:ext cx="3619500" cy="438150"/>
           </a:xfrm>
           <a:prstGeom prst="rect">
             <a:avLst/>
@@ -3806,7 +3731,7 @@
               <a:buNone/>
             </a:pPr>
             <a:r>
-              <a:rPr lang="en-US" sz="3900" dirty="0" spc="-1" kern="0">
+              <a:rPr lang="en-US" sz="2550" dirty="0" spc="6" kern="0">
                 <a:solidFill>
                   <a:srgbClr val="FF6A4D"/>
                 </a:solidFill>
@@ -3816,20 +3741,20 @@
               </a:rPr>
               <a:t>SSL</a:t>
             </a:r>
-            <a:endParaRPr lang="en-US" sz="3900" dirty="0"/>
+            <a:endParaRPr lang="en-US" sz="2550" dirty="0"/>
           </a:p>
         </p:txBody>
       </p:sp>
       <p:sp>
         <p:nvSpPr>
-          <p:cNvPr id="10" name="Text 8"/>
-          <p:cNvSpPr/>
-          <p:nvPr/>
-        </p:nvSpPr>
-        <p:spPr>
-          <a:xfrm>
-            <a:off x="5334000" y="3638550"/>
-            <a:ext cx="3486150" cy="304800"/>
+          <p:cNvPr id="9" name="Text 7"/>
+          <p:cNvSpPr/>
+          <p:nvPr/>
+        </p:nvSpPr>
+        <p:spPr>
+          <a:xfrm>
+            <a:off x="5257800" y="2286000"/>
+            <a:ext cx="3619500" cy="304800"/>
           </a:xfrm>
           <a:prstGeom prst="rect">
             <a:avLst/>
@@ -3883,14 +3808,14 @@
       </p:sp>
       <p:sp>
         <p:nvSpPr>
-          <p:cNvPr id="11" name="Text 9"/>
-          <p:cNvSpPr/>
-          <p:nvPr/>
-        </p:nvSpPr>
-        <p:spPr>
-          <a:xfrm>
-            <a:off x="5334000" y="4000500"/>
-            <a:ext cx="3429000" cy="666750"/>
+          <p:cNvPr id="10" name="Text 8"/>
+          <p:cNvSpPr/>
+          <p:nvPr/>
+        </p:nvSpPr>
+        <p:spPr>
+          <a:xfrm>
+            <a:off x="5257800" y="2647950"/>
+            <a:ext cx="3619500" cy="647700"/>
           </a:xfrm>
           <a:prstGeom prst="rect">
             <a:avLst/>
@@ -3899,17 +3824,17 @@
           <a:ln/>
         </p:spPr>
         <p:txBody>
-          <a:bodyPr wrap="square" lIns="0" tIns="9716" rIns="0" bIns="-9716" rtlCol="0" anchor="t"/>
+          <a:bodyPr wrap="square" lIns="0" tIns="8906" rIns="0" bIns="-8906" rtlCol="0" anchor="t"/>
           <a:lstStyle/>
           <a:p>
             <a:pPr algn="l" indent="0" marL="0">
               <a:lnSpc>
-                <a:spcPts val="2340"/>
+                <a:spcPts val="2145"/>
               </a:lnSpc>
               <a:buNone/>
             </a:pPr>
             <a:r>
-              <a:rPr lang="en-US" sz="1800" dirty="0" spc="13" kern="0">
+              <a:rPr lang="en-US" sz="1650" dirty="0" spc="12" kern="0">
                 <a:solidFill>
                   <a:srgbClr val="D8D3C4"/>
                 </a:solidFill>
@@ -3920,7 +3845,7 @@
               <a:t>đời</a:t>
             </a:r>
             <a:r>
-              <a:rPr lang="en-US" sz="1800" dirty="0" spc="5" kern="0">
+              <a:rPr lang="en-US" sz="1650" dirty="0" spc="6" kern="0">
                 <a:solidFill>
                   <a:srgbClr val="D8D3C4"/>
                 </a:solidFill>
@@ -3931,7 +3856,7 @@
               <a:t> trước</a:t>
             </a:r>
             <a:r>
-              <a:rPr lang="en-US" sz="1800" dirty="0" spc="-1" kern="0">
+              <a:rPr lang="en-US" sz="1650" dirty="0" spc="0" kern="0">
                 <a:solidFill>
                   <a:srgbClr val="D8D3C4"/>
                 </a:solidFill>
@@ -3942,7 +3867,7 @@
               <a:t> TLS,</a:t>
             </a:r>
             <a:r>
-              <a:rPr lang="en-US" sz="1800" dirty="0" spc="-2" kern="0">
+              <a:rPr lang="en-US" sz="1650" dirty="0" spc="1" kern="0">
                 <a:solidFill>
                   <a:srgbClr val="D8D3C4"/>
                 </a:solidFill>
@@ -3953,7 +3878,7 @@
               <a:t> không</a:t>
             </a:r>
             <a:r>
-              <a:rPr lang="en-US" sz="1800" dirty="0" spc="-1" kern="0">
+              <a:rPr lang="en-US" sz="1650" dirty="0" spc="-1" kern="0">
                 <a:solidFill>
                   <a:srgbClr val="D8D3C4"/>
                 </a:solidFill>
@@ -3964,7 +3889,7 @@
               <a:t> còn</a:t>
             </a:r>
             <a:r>
-              <a:rPr lang="en-US" sz="1800" dirty="0" spc="-3" kern="0">
+              <a:rPr lang="en-US" sz="1650" dirty="0" spc="0" kern="0">
                 <a:solidFill>
                   <a:srgbClr val="D8D3C4"/>
                 </a:solidFill>
@@ -3972,37 +3897,26 @@
                 <a:ea typeface="Be Vietnam Pro" pitchFamily="34" charset="-122"/>
                 <a:cs typeface="Be Vietnam Pro" pitchFamily="34" charset="-120"/>
               </a:rPr>
-              <a:t> nên</a:t>
-            </a:r>
-            <a:r>
-              <a:rPr lang="en-US" sz="1800" dirty="0" spc="-2" kern="0">
-                <a:solidFill>
-                  <a:srgbClr val="D8D3C4"/>
-                </a:solidFill>
-                <a:latin typeface="Be Vietnam Pro" pitchFamily="34" charset="0"/>
-                <a:ea typeface="Be Vietnam Pro" pitchFamily="34" charset="-122"/>
-                <a:cs typeface="Be Vietnam Pro" pitchFamily="34" charset="-120"/>
-              </a:rPr>
-              <a:t> dùng</a:t>
-            </a:r>
-            <a:endParaRPr lang="en-US" sz="1800" dirty="0"/>
+              <a:t> nên dùng</a:t>
+            </a:r>
+            <a:endParaRPr lang="en-US" sz="1650" dirty="0"/>
           </a:p>
         </p:txBody>
       </p:sp>
       <p:sp>
         <p:nvSpPr>
-          <p:cNvPr id="12" name="Shape 10"/>
-          <p:cNvSpPr/>
-          <p:nvPr/>
-        </p:nvSpPr>
-        <p:spPr>
-          <a:xfrm>
-            <a:off x="9296400" y="2762250"/>
-            <a:ext cx="3886200" cy="2000250"/>
+          <p:cNvPr id="11" name="Shape 9"/>
+          <p:cNvSpPr/>
+          <p:nvPr/>
+        </p:nvSpPr>
+        <p:spPr>
+          <a:xfrm>
+            <a:off x="9220200" y="1485900"/>
+            <a:ext cx="4000500" cy="1866900"/>
           </a:xfrm>
           <a:prstGeom prst="roundRect">
             <a:avLst>
-              <a:gd name="adj" fmla="val 11429"/>
+              <a:gd name="adj" fmla="val 11224"/>
             </a:avLst>
           </a:prstGeom>
           <a:solidFill>
@@ -4018,14 +3932,14 @@
       </p:sp>
       <p:sp>
         <p:nvSpPr>
-          <p:cNvPr id="13" name="Text 11"/>
-          <p:cNvSpPr/>
-          <p:nvPr/>
-        </p:nvSpPr>
-        <p:spPr>
-          <a:xfrm>
-            <a:off x="9525000" y="2933700"/>
-            <a:ext cx="3429000" cy="666750"/>
+          <p:cNvPr id="12" name="Text 10"/>
+          <p:cNvSpPr/>
+          <p:nvPr/>
+        </p:nvSpPr>
+        <p:spPr>
+          <a:xfrm>
+            <a:off x="9410700" y="1809750"/>
+            <a:ext cx="3619500" cy="438150"/>
           </a:xfrm>
           <a:prstGeom prst="rect">
             <a:avLst/>
@@ -4041,7 +3955,7 @@
               <a:buNone/>
             </a:pPr>
             <a:r>
-              <a:rPr lang="en-US" sz="3900" dirty="0" spc="-11" kern="0">
+              <a:rPr lang="en-US" sz="2550" dirty="0" spc="-2" kern="0">
                 <a:solidFill>
                   <a:srgbClr val="FFB454"/>
                 </a:solidFill>
@@ -4051,20 +3965,20 @@
               </a:rPr>
               <a:t>AES</a:t>
             </a:r>
-            <a:endParaRPr lang="en-US" sz="3900" dirty="0"/>
+            <a:endParaRPr lang="en-US" sz="2550" dirty="0"/>
           </a:p>
         </p:txBody>
       </p:sp>
       <p:sp>
         <p:nvSpPr>
-          <p:cNvPr id="14" name="Text 12"/>
-          <p:cNvSpPr/>
-          <p:nvPr/>
-        </p:nvSpPr>
-        <p:spPr>
-          <a:xfrm>
-            <a:off x="9525000" y="3638550"/>
-            <a:ext cx="3486150" cy="304800"/>
+          <p:cNvPr id="13" name="Text 11"/>
+          <p:cNvSpPr/>
+          <p:nvPr/>
+        </p:nvSpPr>
+        <p:spPr>
+          <a:xfrm>
+            <a:off x="9410700" y="2286000"/>
+            <a:ext cx="3619500" cy="304800"/>
           </a:xfrm>
           <a:prstGeom prst="rect">
             <a:avLst/>
@@ -4118,14 +4032,14 @@
       </p:sp>
       <p:sp>
         <p:nvSpPr>
-          <p:cNvPr id="15" name="Text 13"/>
-          <p:cNvSpPr/>
-          <p:nvPr/>
-        </p:nvSpPr>
-        <p:spPr>
-          <a:xfrm>
-            <a:off x="9525000" y="4000500"/>
-            <a:ext cx="3429000" cy="666750"/>
+          <p:cNvPr id="14" name="Text 12"/>
+          <p:cNvSpPr/>
+          <p:nvPr/>
+        </p:nvSpPr>
+        <p:spPr>
+          <a:xfrm>
+            <a:off x="9410700" y="2647950"/>
+            <a:ext cx="3619500" cy="647700"/>
           </a:xfrm>
           <a:prstGeom prst="rect">
             <a:avLst/>
@@ -4134,17 +4048,17 @@
           <a:ln/>
         </p:spPr>
         <p:txBody>
-          <a:bodyPr wrap="square" lIns="0" tIns="9716" rIns="0" bIns="-9716" rtlCol="0" anchor="t"/>
+          <a:bodyPr wrap="square" lIns="0" tIns="8906" rIns="0" bIns="-8906" rtlCol="0" anchor="t"/>
           <a:lstStyle/>
           <a:p>
             <a:pPr algn="l" indent="0" marL="0">
               <a:lnSpc>
-                <a:spcPts val="2340"/>
+                <a:spcPts val="2145"/>
               </a:lnSpc>
               <a:buNone/>
             </a:pPr>
             <a:r>
-              <a:rPr lang="en-US" sz="1800" dirty="0" spc="-10" kern="0">
+              <a:rPr lang="en-US" sz="1650" dirty="0" spc="-2" kern="0">
                 <a:solidFill>
                   <a:srgbClr val="D8D3C4"/>
                 </a:solidFill>
@@ -4152,10 +4066,10 @@
                 <a:ea typeface="Be Vietnam Pro" pitchFamily="34" charset="-122"/>
                 <a:cs typeface="Be Vietnam Pro" pitchFamily="34" charset="-120"/>
               </a:rPr>
-              <a:t>một</a:t>
-            </a:r>
-            <a:r>
-              <a:rPr lang="en-US" sz="1800" dirty="0" spc="-1" kern="0">
+              <a:t>khóa</a:t>
+            </a:r>
+            <a:r>
+              <a:rPr lang="en-US" sz="1650" dirty="0" spc="-1" kern="0">
                 <a:solidFill>
                   <a:srgbClr val="D8D3C4"/>
                 </a:solidFill>
@@ -4163,10 +4077,10 @@
                 <a:ea typeface="Be Vietnam Pro" pitchFamily="34" charset="-122"/>
                 <a:cs typeface="Be Vietnam Pro" pitchFamily="34" charset="-120"/>
               </a:rPr>
-              <a:t> khóa</a:t>
-            </a:r>
-            <a:r>
-              <a:rPr lang="en-US" sz="1800" dirty="0" spc="-2" kern="0">
+              <a:t> chung</a:t>
+            </a:r>
+            <a:r>
+              <a:rPr lang="en-US" sz="1650" dirty="0" spc="15" kern="0">
                 <a:solidFill>
                   <a:srgbClr val="D8D3C4"/>
                 </a:solidFill>
@@ -4174,10 +4088,10 @@
                 <a:ea typeface="Be Vietnam Pro" pitchFamily="34" charset="-122"/>
                 <a:cs typeface="Be Vietnam Pro" pitchFamily="34" charset="-120"/>
               </a:rPr>
-              <a:t> chung</a:t>
-            </a:r>
-            <a:r>
-              <a:rPr lang="en-US" sz="1800" dirty="0" spc="13" kern="0">
+              <a:t> để</a:t>
+            </a:r>
+            <a:r>
+              <a:rPr lang="en-US" sz="1650" dirty="0" spc="2" kern="0">
                 <a:solidFill>
                   <a:srgbClr val="D8D3C4"/>
                 </a:solidFill>
@@ -4185,10 +4099,10 @@
                 <a:ea typeface="Be Vietnam Pro" pitchFamily="34" charset="-122"/>
                 <a:cs typeface="Be Vietnam Pro" pitchFamily="34" charset="-120"/>
               </a:rPr>
-              <a:t> để</a:t>
-            </a:r>
-            <a:r>
-              <a:rPr lang="en-US" sz="1800" dirty="0" spc="-2" kern="0">
+              <a:t> mã</a:t>
+            </a:r>
+            <a:r>
+              <a:rPr lang="en-US" sz="1650" dirty="0" spc="-1" kern="0">
                 <a:solidFill>
                   <a:srgbClr val="D8D3C4"/>
                 </a:solidFill>
@@ -4196,70 +4110,48 @@
                 <a:ea typeface="Be Vietnam Pro" pitchFamily="34" charset="-122"/>
                 <a:cs typeface="Be Vietnam Pro" pitchFamily="34" charset="-120"/>
               </a:rPr>
+              <a:t> hóa,</a:t>
+            </a:r>
+            <a:r>
+              <a:rPr lang="en-US" sz="1650" dirty="0" spc="0" kern="0">
+                <a:solidFill>
+                  <a:srgbClr val="D8D3C4"/>
+                </a:solidFill>
+                <a:latin typeface="Be Vietnam Pro" pitchFamily="34" charset="0"/>
+                <a:ea typeface="Be Vietnam Pro" pitchFamily="34" charset="-122"/>
+                <a:cs typeface="Be Vietnam Pro" pitchFamily="34" charset="-120"/>
+              </a:rPr>
+              <a:t> giải</a:t>
+            </a:r>
+            <a:r>
+              <a:rPr lang="en-US" sz="1650" dirty="0" spc="2" kern="0">
+                <a:solidFill>
+                  <a:srgbClr val="D8D3C4"/>
+                </a:solidFill>
+                <a:latin typeface="Be Vietnam Pro" pitchFamily="34" charset="0"/>
+                <a:ea typeface="Be Vietnam Pro" pitchFamily="34" charset="-122"/>
+                <a:cs typeface="Be Vietnam Pro" pitchFamily="34" charset="-120"/>
+              </a:rPr>
               <a:t> mã</a:t>
             </a:r>
-            <a:r>
-              <a:rPr lang="en-US" sz="1800" dirty="0" spc="-1" kern="0">
-                <a:solidFill>
-                  <a:srgbClr val="D8D3C4"/>
-                </a:solidFill>
-                <a:latin typeface="Be Vietnam Pro" pitchFamily="34" charset="0"/>
-                <a:ea typeface="Be Vietnam Pro" pitchFamily="34" charset="-122"/>
-                <a:cs typeface="Be Vietnam Pro" pitchFamily="34" charset="-120"/>
-              </a:rPr>
-              <a:t> hóa</a:t>
-            </a:r>
-            <a:r>
-              <a:rPr lang="en-US" sz="1800" dirty="0" spc="-11" kern="0">
-                <a:solidFill>
-                  <a:srgbClr val="D8D3C4"/>
-                </a:solidFill>
-                <a:latin typeface="Be Vietnam Pro" pitchFamily="34" charset="0"/>
-                <a:ea typeface="Be Vietnam Pro" pitchFamily="34" charset="-122"/>
-                <a:cs typeface="Be Vietnam Pro" pitchFamily="34" charset="-120"/>
-              </a:rPr>
-              <a:t> và</a:t>
-            </a:r>
-            <a:r>
-              <a:rPr lang="en-US" sz="1800" dirty="0" spc="-1" kern="0">
-                <a:solidFill>
-                  <a:srgbClr val="D8D3C4"/>
-                </a:solidFill>
-                <a:latin typeface="Be Vietnam Pro" pitchFamily="34" charset="0"/>
-                <a:ea typeface="Be Vietnam Pro" pitchFamily="34" charset="-122"/>
-                <a:cs typeface="Be Vietnam Pro" pitchFamily="34" charset="-120"/>
-              </a:rPr>
-              <a:t> giải</a:t>
-            </a:r>
-            <a:r>
-              <a:rPr lang="en-US" sz="1800" dirty="0" spc="0" kern="0">
-                <a:solidFill>
-                  <a:srgbClr val="D8D3C4"/>
-                </a:solidFill>
-                <a:latin typeface="Be Vietnam Pro" pitchFamily="34" charset="0"/>
-                <a:ea typeface="Be Vietnam Pro" pitchFamily="34" charset="-122"/>
-                <a:cs typeface="Be Vietnam Pro" pitchFamily="34" charset="-120"/>
-              </a:rPr>
-              <a:t> mã</a:t>
-            </a:r>
-            <a:endParaRPr lang="en-US" sz="1800" dirty="0"/>
+            <a:endParaRPr lang="en-US" sz="1650" dirty="0"/>
           </a:p>
         </p:txBody>
       </p:sp>
       <p:sp>
         <p:nvSpPr>
-          <p:cNvPr id="16" name="Shape 14"/>
-          <p:cNvSpPr/>
-          <p:nvPr/>
-        </p:nvSpPr>
-        <p:spPr>
-          <a:xfrm>
-            <a:off x="13487400" y="2762250"/>
-            <a:ext cx="3886200" cy="2000250"/>
+          <p:cNvPr id="15" name="Shape 13"/>
+          <p:cNvSpPr/>
+          <p:nvPr/>
+        </p:nvSpPr>
+        <p:spPr>
+          <a:xfrm>
+            <a:off x="13373100" y="1485900"/>
+            <a:ext cx="4000500" cy="1866900"/>
           </a:xfrm>
           <a:prstGeom prst="roundRect">
             <a:avLst>
-              <a:gd name="adj" fmla="val 11429"/>
+              <a:gd name="adj" fmla="val 11224"/>
             </a:avLst>
           </a:prstGeom>
           <a:solidFill>
@@ -4275,14 +4167,14 @@
       </p:sp>
       <p:sp>
         <p:nvSpPr>
-          <p:cNvPr id="17" name="Text 15"/>
-          <p:cNvSpPr/>
-          <p:nvPr/>
-        </p:nvSpPr>
-        <p:spPr>
-          <a:xfrm>
-            <a:off x="13716000" y="2933700"/>
-            <a:ext cx="3429000" cy="666750"/>
+          <p:cNvPr id="16" name="Text 14"/>
+          <p:cNvSpPr/>
+          <p:nvPr/>
+        </p:nvSpPr>
+        <p:spPr>
+          <a:xfrm>
+            <a:off x="13563600" y="1809750"/>
+            <a:ext cx="3619500" cy="438150"/>
           </a:xfrm>
           <a:prstGeom prst="rect">
             <a:avLst/>
@@ -4298,7 +4190,7 @@
               <a:buNone/>
             </a:pPr>
             <a:r>
-              <a:rPr lang="en-US" sz="3900" dirty="0" spc="3" kern="0">
+              <a:rPr lang="en-US" sz="2550" dirty="0" spc="-1" kern="0">
                 <a:solidFill>
                   <a:srgbClr val="FFB454"/>
                 </a:solidFill>
@@ -4308,20 +4200,20 @@
               </a:rPr>
               <a:t>GCM</a:t>
             </a:r>
-            <a:endParaRPr lang="en-US" sz="3900" dirty="0"/>
+            <a:endParaRPr lang="en-US" sz="2550" dirty="0"/>
           </a:p>
         </p:txBody>
       </p:sp>
       <p:sp>
         <p:nvSpPr>
-          <p:cNvPr id="18" name="Text 16"/>
-          <p:cNvSpPr/>
-          <p:nvPr/>
-        </p:nvSpPr>
-        <p:spPr>
-          <a:xfrm>
-            <a:off x="13716000" y="3638550"/>
-            <a:ext cx="3486150" cy="304800"/>
+          <p:cNvPr id="17" name="Text 15"/>
+          <p:cNvSpPr/>
+          <p:nvPr/>
+        </p:nvSpPr>
+        <p:spPr>
+          <a:xfrm>
+            <a:off x="13563600" y="2286000"/>
+            <a:ext cx="3619500" cy="304800"/>
           </a:xfrm>
           <a:prstGeom prst="rect">
             <a:avLst/>
@@ -4375,14 +4267,14 @@
       </p:sp>
       <p:sp>
         <p:nvSpPr>
-          <p:cNvPr id="19" name="Text 17"/>
-          <p:cNvSpPr/>
-          <p:nvPr/>
-        </p:nvSpPr>
-        <p:spPr>
-          <a:xfrm>
-            <a:off x="13716000" y="4000500"/>
-            <a:ext cx="3429000" cy="666750"/>
+          <p:cNvPr id="18" name="Text 16"/>
+          <p:cNvSpPr/>
+          <p:nvPr/>
+        </p:nvSpPr>
+        <p:spPr>
+          <a:xfrm>
+            <a:off x="13563600" y="2647950"/>
+            <a:ext cx="3619500" cy="647700"/>
           </a:xfrm>
           <a:prstGeom prst="rect">
             <a:avLst/>
@@ -4391,17 +4283,17 @@
           <a:ln/>
         </p:spPr>
         <p:txBody>
-          <a:bodyPr wrap="square" lIns="0" tIns="9716" rIns="0" bIns="-9716" rtlCol="0" anchor="t"/>
+          <a:bodyPr wrap="square" lIns="0" tIns="8906" rIns="0" bIns="-8906" rtlCol="0" anchor="t"/>
           <a:lstStyle/>
           <a:p>
             <a:pPr algn="l" indent="0" marL="0">
               <a:lnSpc>
-                <a:spcPts val="2340"/>
+                <a:spcPts val="2145"/>
               </a:lnSpc>
               <a:buNone/>
             </a:pPr>
             <a:r>
-              <a:rPr lang="en-US" sz="1800" dirty="0" spc="11" kern="0">
+              <a:rPr lang="en-US" sz="1650" dirty="0" spc="7" kern="0">
                 <a:solidFill>
                   <a:srgbClr val="D8D3C4"/>
                 </a:solidFill>
@@ -4412,7 +4304,7 @@
               <a:t>vừa</a:t>
             </a:r>
             <a:r>
-              <a:rPr lang="en-US" sz="1800" dirty="0" spc="-1" kern="0">
+              <a:rPr lang="en-US" sz="1650" dirty="0" spc="2" kern="0">
                 <a:solidFill>
                   <a:srgbClr val="D8D3C4"/>
                 </a:solidFill>
@@ -4420,10 +4312,10 @@
                 <a:ea typeface="Be Vietnam Pro" pitchFamily="34" charset="-122"/>
                 <a:cs typeface="Be Vietnam Pro" pitchFamily="34" charset="-120"/>
               </a:rPr>
-              <a:t> mã hóa</a:t>
-            </a:r>
-            <a:r>
-              <a:rPr lang="en-US" sz="1800" dirty="0" spc="9" kern="0">
+              <a:t> mã</a:t>
+            </a:r>
+            <a:r>
+              <a:rPr lang="en-US" sz="1650" dirty="0" spc="-2" kern="0">
                 <a:solidFill>
                   <a:srgbClr val="D8D3C4"/>
                 </a:solidFill>
@@ -4431,10 +4323,21 @@
                 <a:ea typeface="Be Vietnam Pro" pitchFamily="34" charset="-122"/>
                 <a:cs typeface="Be Vietnam Pro" pitchFamily="34" charset="-120"/>
               </a:rPr>
+              <a:t> hóa</a:t>
+            </a:r>
+            <a:r>
+              <a:rPr lang="en-US" sz="1650" dirty="0" spc="7" kern="0">
+                <a:solidFill>
+                  <a:srgbClr val="D8D3C4"/>
+                </a:solidFill>
+                <a:latin typeface="Be Vietnam Pro" pitchFamily="34" charset="0"/>
+                <a:ea typeface="Be Vietnam Pro" pitchFamily="34" charset="-122"/>
+                <a:cs typeface="Be Vietnam Pro" pitchFamily="34" charset="-120"/>
+              </a:rPr>
               <a:t> vừa</a:t>
             </a:r>
             <a:r>
-              <a:rPr lang="en-US" sz="1800" dirty="0" spc="-12" kern="0">
+              <a:rPr lang="en-US" sz="1650" dirty="0" spc="-8" kern="0">
                 <a:solidFill>
                   <a:srgbClr val="D8D3C4"/>
                 </a:solidFill>
@@ -4445,7 +4348,7 @@
               <a:t> gắn</a:t>
             </a:r>
             <a:r>
-              <a:rPr lang="en-US" sz="1800" dirty="0" spc="-2" kern="0">
+              <a:rPr lang="en-US" sz="1650" dirty="0" spc="4" kern="0">
                 <a:solidFill>
                   <a:srgbClr val="D8D3C4"/>
                 </a:solidFill>
@@ -4456,7 +4359,7 @@
               <a:t> thẻ</a:t>
             </a:r>
             <a:r>
-              <a:rPr lang="en-US" sz="1800" dirty="0" spc="-1" kern="0">
+              <a:rPr lang="en-US" sz="1650" dirty="0" spc="2" kern="0">
                 <a:solidFill>
                   <a:srgbClr val="D8D3C4"/>
                 </a:solidFill>
@@ -4467,7 +4370,7 @@
               <a:t> kiểm</a:t>
             </a:r>
             <a:r>
-              <a:rPr lang="en-US" sz="1800" dirty="0" spc="-16" kern="0">
+              <a:rPr lang="en-US" sz="1650" dirty="0" spc="-16" kern="0">
                 <a:solidFill>
                   <a:srgbClr val="D8D3C4"/>
                 </a:solidFill>
@@ -4477,24 +4380,24 @@
               </a:rPr>
               <a:t> tra</a:t>
             </a:r>
-            <a:endParaRPr lang="en-US" sz="1800" dirty="0"/>
+            <a:endParaRPr lang="en-US" sz="1650" dirty="0"/>
           </a:p>
         </p:txBody>
       </p:sp>
       <p:sp>
         <p:nvSpPr>
-          <p:cNvPr id="20" name="Shape 18"/>
-          <p:cNvSpPr/>
-          <p:nvPr/>
-        </p:nvSpPr>
-        <p:spPr>
-          <a:xfrm>
-            <a:off x="914400" y="4953000"/>
-            <a:ext cx="3886200" cy="2000250"/>
+          <p:cNvPr id="19" name="Shape 17"/>
+          <p:cNvSpPr/>
+          <p:nvPr/>
+        </p:nvSpPr>
+        <p:spPr>
+          <a:xfrm>
+            <a:off x="914400" y="3505200"/>
+            <a:ext cx="5381625" cy="1866900"/>
           </a:xfrm>
           <a:prstGeom prst="roundRect">
             <a:avLst>
-              <a:gd name="adj" fmla="val 11429"/>
+              <a:gd name="adj" fmla="val 11224"/>
             </a:avLst>
           </a:prstGeom>
           <a:solidFill>
@@ -4510,14 +4413,14 @@
       </p:sp>
       <p:sp>
         <p:nvSpPr>
-          <p:cNvPr id="21" name="Text 19"/>
-          <p:cNvSpPr/>
-          <p:nvPr/>
-        </p:nvSpPr>
-        <p:spPr>
-          <a:xfrm>
-            <a:off x="1143000" y="5124450"/>
-            <a:ext cx="3429000" cy="666750"/>
+          <p:cNvPr id="20" name="Text 18"/>
+          <p:cNvSpPr/>
+          <p:nvPr/>
+        </p:nvSpPr>
+        <p:spPr>
+          <a:xfrm>
+            <a:off x="1104900" y="3829050"/>
+            <a:ext cx="5000625" cy="438150"/>
           </a:xfrm>
           <a:prstGeom prst="rect">
             <a:avLst/>
@@ -4533,7 +4436,7 @@
               <a:buNone/>
             </a:pPr>
             <a:r>
-              <a:rPr lang="en-US" sz="3900" dirty="0" spc="3" kern="0">
+              <a:rPr lang="en-US" sz="2550" dirty="0" spc="-6" kern="0">
                 <a:solidFill>
                   <a:srgbClr val="FFB454"/>
                 </a:solidFill>
@@ -4541,22 +4444,22 @@
                 <a:ea typeface="Bricolage Grotesque ExtraBold" pitchFamily="34" charset="-122"/>
                 <a:cs typeface="Bricolage Grotesque ExtraBold" pitchFamily="34" charset="-120"/>
               </a:rPr>
-              <a:t>DEK</a:t>
-            </a:r>
-            <a:endParaRPr lang="en-US" sz="3900" dirty="0"/>
+              <a:t>CTR</a:t>
+            </a:r>
+            <a:endParaRPr lang="en-US" sz="2550" dirty="0"/>
           </a:p>
         </p:txBody>
       </p:sp>
       <p:sp>
         <p:nvSpPr>
-          <p:cNvPr id="22" name="Text 20"/>
-          <p:cNvSpPr/>
-          <p:nvPr/>
-        </p:nvSpPr>
-        <p:spPr>
-          <a:xfrm>
-            <a:off x="1143000" y="5829300"/>
-            <a:ext cx="3486150" cy="304800"/>
+          <p:cNvPr id="21" name="Text 19"/>
+          <p:cNvSpPr/>
+          <p:nvPr/>
+        </p:nvSpPr>
+        <p:spPr>
+          <a:xfrm>
+            <a:off x="1104900" y="4305300"/>
+            <a:ext cx="5000625" cy="304800"/>
           </a:xfrm>
           <a:prstGeom prst="rect">
             <a:avLst/>
@@ -4572,7 +4475,7 @@
               <a:buNone/>
             </a:pPr>
             <a:r>
-              <a:rPr lang="en-US" sz="1650" dirty="0" spc="-8" kern="0">
+              <a:rPr lang="en-US" sz="1650" dirty="0" spc="-39" kern="0">
                 <a:solidFill>
                   <a:srgbClr val="9A98A0"/>
                 </a:solidFill>
@@ -4580,29 +4483,7 @@
                 <a:ea typeface="Be Vietnam Pro SemiBold" pitchFamily="34" charset="-122"/>
                 <a:cs typeface="Be Vietnam Pro SemiBold" pitchFamily="34" charset="-120"/>
               </a:rPr>
-              <a:t>Data</a:t>
-            </a:r>
-            <a:r>
-              <a:rPr lang="en-US" sz="1650" dirty="0" spc="-2" kern="0">
-                <a:solidFill>
-                  <a:srgbClr val="9A98A0"/>
-                </a:solidFill>
-                <a:latin typeface="Be Vietnam Pro SemiBold" pitchFamily="34" charset="0"/>
-                <a:ea typeface="Be Vietnam Pro SemiBold" pitchFamily="34" charset="-122"/>
-                <a:cs typeface="Be Vietnam Pro SemiBold" pitchFamily="34" charset="-120"/>
-              </a:rPr>
-              <a:t> Encryption</a:t>
-            </a:r>
-            <a:r>
-              <a:rPr lang="en-US" sz="1650" dirty="0" spc="-31" kern="0">
-                <a:solidFill>
-                  <a:srgbClr val="9A98A0"/>
-                </a:solidFill>
-                <a:latin typeface="Be Vietnam Pro SemiBold" pitchFamily="34" charset="0"/>
-                <a:ea typeface="Be Vietnam Pro SemiBold" pitchFamily="34" charset="-122"/>
-                <a:cs typeface="Be Vietnam Pro SemiBold" pitchFamily="34" charset="-120"/>
-              </a:rPr>
-              <a:t> Key</a:t>
+              <a:t>CounTeR</a:t>
             </a:r>
             <a:endParaRPr lang="en-US" sz="1650" dirty="0"/>
           </a:p>
@@ -4610,14 +4491,14 @@
       </p:sp>
       <p:sp>
         <p:nvSpPr>
-          <p:cNvPr id="23" name="Text 21"/>
-          <p:cNvSpPr/>
-          <p:nvPr/>
-        </p:nvSpPr>
-        <p:spPr>
-          <a:xfrm>
-            <a:off x="1143000" y="6191250"/>
-            <a:ext cx="3429000" cy="666750"/>
+          <p:cNvPr id="22" name="Text 20"/>
+          <p:cNvSpPr/>
+          <p:nvPr/>
+        </p:nvSpPr>
+        <p:spPr>
+          <a:xfrm>
+            <a:off x="1104900" y="4667250"/>
+            <a:ext cx="5000625" cy="647700"/>
           </a:xfrm>
           <a:prstGeom prst="rect">
             <a:avLst/>
@@ -4626,17 +4507,17 @@
           <a:ln/>
         </p:spPr>
         <p:txBody>
-          <a:bodyPr wrap="square" lIns="0" tIns="9716" rIns="0" bIns="-9716" rtlCol="0" anchor="t"/>
+          <a:bodyPr wrap="square" lIns="0" tIns="8906" rIns="0" bIns="-8906" rtlCol="0" anchor="t"/>
           <a:lstStyle/>
           <a:p>
             <a:pPr algn="l" indent="0" marL="0">
               <a:lnSpc>
-                <a:spcPts val="2340"/>
+                <a:spcPts val="2145"/>
               </a:lnSpc>
               <a:buNone/>
             </a:pPr>
             <a:r>
-              <a:rPr lang="en-US" sz="1800" dirty="0" spc="-2" kern="0">
+              <a:rPr lang="en-US" sz="1650" dirty="0" spc="1" kern="0">
                 <a:solidFill>
                   <a:srgbClr val="D8D3C4"/>
                 </a:solidFill>
@@ -4644,10 +4525,10 @@
                 <a:ea typeface="Be Vietnam Pro" pitchFamily="34" charset="-122"/>
                 <a:cs typeface="Be Vietnam Pro" pitchFamily="34" charset="-120"/>
               </a:rPr>
-              <a:t>khóa</a:t>
-            </a:r>
-            <a:r>
-              <a:rPr lang="en-US" sz="1800" dirty="0" spc="7" kern="0">
+              <a:t>chế</a:t>
+            </a:r>
+            <a:r>
+              <a:rPr lang="en-US" sz="1650" dirty="0" spc="14" kern="0">
                 <a:solidFill>
                   <a:srgbClr val="D8D3C4"/>
                 </a:solidFill>
@@ -4655,10 +4536,10 @@
                 <a:ea typeface="Be Vietnam Pro" pitchFamily="34" charset="-122"/>
                 <a:cs typeface="Be Vietnam Pro" pitchFamily="34" charset="-120"/>
               </a:rPr>
-              <a:t> trực</a:t>
-            </a:r>
-            <a:r>
-              <a:rPr lang="en-US" sz="1800" dirty="0" spc="-1" kern="0">
+              <a:t> độ</a:t>
+            </a:r>
+            <a:r>
+              <a:rPr lang="en-US" sz="1650" dirty="0" spc="9" kern="0">
                 <a:solidFill>
                   <a:srgbClr val="D8D3C4"/>
                 </a:solidFill>
@@ -4666,10 +4547,10 @@
                 <a:ea typeface="Be Vietnam Pro" pitchFamily="34" charset="-122"/>
                 <a:cs typeface="Be Vietnam Pro" pitchFamily="34" charset="-120"/>
               </a:rPr>
-              <a:t> tiếp</a:t>
-            </a:r>
-            <a:r>
-              <a:rPr lang="en-US" sz="1800" dirty="0" spc="-2" kern="0">
+              <a:t> đếm,</a:t>
+            </a:r>
+            <a:r>
+              <a:rPr lang="en-US" sz="1650" dirty="0" spc="1" kern="0">
                 <a:solidFill>
                   <a:srgbClr val="D8D3C4"/>
                 </a:solidFill>
@@ -4677,10 +4558,10 @@
                 <a:ea typeface="Be Vietnam Pro" pitchFamily="34" charset="-122"/>
                 <a:cs typeface="Be Vietnam Pro" pitchFamily="34" charset="-120"/>
               </a:rPr>
-              <a:t> mã</a:t>
-            </a:r>
-            <a:r>
-              <a:rPr lang="en-US" sz="1800" dirty="0" spc="-1" kern="0">
+              <a:t> không có</a:t>
+            </a:r>
+            <a:r>
+              <a:rPr lang="en-US" sz="1650" dirty="0" spc="4" kern="0">
                 <a:solidFill>
                   <a:srgbClr val="D8D3C4"/>
                 </a:solidFill>
@@ -4688,10 +4569,10 @@
                 <a:ea typeface="Be Vietnam Pro" pitchFamily="34" charset="-122"/>
                 <a:cs typeface="Be Vietnam Pro" pitchFamily="34" charset="-120"/>
               </a:rPr>
-              <a:t> hóa</a:t>
-            </a:r>
-            <a:r>
-              <a:rPr lang="en-US" sz="1800" dirty="0" spc="1" kern="0">
+              <a:t> thẻ</a:t>
+            </a:r>
+            <a:r>
+              <a:rPr lang="en-US" sz="1650" dirty="0" spc="1" kern="0">
                 <a:solidFill>
                   <a:srgbClr val="D8D3C4"/>
                 </a:solidFill>
@@ -4699,10 +4580,10 @@
                 <a:ea typeface="Be Vietnam Pro" pitchFamily="34" charset="-122"/>
                 <a:cs typeface="Be Vietnam Pro" pitchFamily="34" charset="-120"/>
               </a:rPr>
-              <a:t> dữ</a:t>
-            </a:r>
-            <a:r>
-              <a:rPr lang="en-US" sz="1800" dirty="0" spc="-3" kern="0">
+              <a:t> kiểm</a:t>
+            </a:r>
+            <a:r>
+              <a:rPr lang="en-US" sz="1650" dirty="0" spc="-15" kern="0">
                 <a:solidFill>
                   <a:srgbClr val="D8D3C4"/>
                 </a:solidFill>
@@ -4710,26 +4591,26 @@
                 <a:ea typeface="Be Vietnam Pro" pitchFamily="34" charset="-122"/>
                 <a:cs typeface="Be Vietnam Pro" pitchFamily="34" charset="-120"/>
               </a:rPr>
-              <a:t> liệu</a:t>
-            </a:r>
-            <a:endParaRPr lang="en-US" sz="1800" dirty="0"/>
+              <a:t> tra</a:t>
+            </a:r>
+            <a:endParaRPr lang="en-US" sz="1650" dirty="0"/>
           </a:p>
         </p:txBody>
       </p:sp>
       <p:sp>
         <p:nvSpPr>
-          <p:cNvPr id="24" name="Shape 22"/>
-          <p:cNvSpPr/>
-          <p:nvPr/>
-        </p:nvSpPr>
-        <p:spPr>
-          <a:xfrm>
-            <a:off x="5105400" y="4953000"/>
-            <a:ext cx="3886200" cy="2000250"/>
+          <p:cNvPr id="23" name="Shape 21"/>
+          <p:cNvSpPr/>
+          <p:nvPr/>
+        </p:nvSpPr>
+        <p:spPr>
+          <a:xfrm>
+            <a:off x="6448425" y="3505200"/>
+            <a:ext cx="5381625" cy="1866900"/>
           </a:xfrm>
           <a:prstGeom prst="roundRect">
             <a:avLst>
-              <a:gd name="adj" fmla="val 11429"/>
+              <a:gd name="adj" fmla="val 11224"/>
             </a:avLst>
           </a:prstGeom>
           <a:solidFill>
@@ -4745,14 +4626,14 @@
       </p:sp>
       <p:sp>
         <p:nvSpPr>
-          <p:cNvPr id="25" name="Text 23"/>
-          <p:cNvSpPr/>
-          <p:nvPr/>
-        </p:nvSpPr>
-        <p:spPr>
-          <a:xfrm>
-            <a:off x="5334000" y="5124450"/>
-            <a:ext cx="3429000" cy="666750"/>
+          <p:cNvPr id="24" name="Text 22"/>
+          <p:cNvSpPr/>
+          <p:nvPr/>
+        </p:nvSpPr>
+        <p:spPr>
+          <a:xfrm>
+            <a:off x="6638925" y="3829050"/>
+            <a:ext cx="5000625" cy="438150"/>
           </a:xfrm>
           <a:prstGeom prst="rect">
             <a:avLst/>
@@ -4768,7 +4649,7 @@
               <a:buNone/>
             </a:pPr>
             <a:r>
-              <a:rPr lang="en-US" sz="3900" dirty="0" spc="5" kern="0">
+              <a:rPr lang="en-US" sz="2550" dirty="0" kern="0">
                 <a:solidFill>
                   <a:srgbClr val="FFB454"/>
                 </a:solidFill>
@@ -4776,22 +4657,22 @@
                 <a:ea typeface="Bricolage Grotesque ExtraBold" pitchFamily="34" charset="-122"/>
                 <a:cs typeface="Bricolage Grotesque ExtraBold" pitchFamily="34" charset="-120"/>
               </a:rPr>
-              <a:t>KEK</a:t>
-            </a:r>
-            <a:endParaRPr lang="en-US" sz="3900" dirty="0"/>
+              <a:t>DEK</a:t>
+            </a:r>
+            <a:endParaRPr lang="en-US" sz="2550" dirty="0"/>
           </a:p>
         </p:txBody>
       </p:sp>
       <p:sp>
         <p:nvSpPr>
-          <p:cNvPr id="26" name="Text 24"/>
-          <p:cNvSpPr/>
-          <p:nvPr/>
-        </p:nvSpPr>
-        <p:spPr>
-          <a:xfrm>
-            <a:off x="5334000" y="5829300"/>
-            <a:ext cx="3486150" cy="304800"/>
+          <p:cNvPr id="25" name="Text 23"/>
+          <p:cNvSpPr/>
+          <p:nvPr/>
+        </p:nvSpPr>
+        <p:spPr>
+          <a:xfrm>
+            <a:off x="6638925" y="4305300"/>
+            <a:ext cx="5000625" cy="304800"/>
           </a:xfrm>
           <a:prstGeom prst="rect">
             <a:avLst/>
@@ -4807,7 +4688,7 @@
               <a:buNone/>
             </a:pPr>
             <a:r>
-              <a:rPr lang="en-US" sz="1650" dirty="0" spc="-44" kern="0">
+              <a:rPr lang="en-US" sz="1650" dirty="0" spc="-8" kern="0">
                 <a:solidFill>
                   <a:srgbClr val="9A98A0"/>
                 </a:solidFill>
@@ -4815,10 +4696,10 @@
                 <a:ea typeface="Be Vietnam Pro SemiBold" pitchFamily="34" charset="-122"/>
                 <a:cs typeface="Be Vietnam Pro SemiBold" pitchFamily="34" charset="-120"/>
               </a:rPr>
-              <a:t>Key</a:t>
-            </a:r>
-            <a:r>
-              <a:rPr lang="en-US" sz="1650" dirty="0" spc="-1" kern="0">
+              <a:t>Data</a:t>
+            </a:r>
+            <a:r>
+              <a:rPr lang="en-US" sz="1650" dirty="0" spc="-2" kern="0">
                 <a:solidFill>
                   <a:srgbClr val="9A98A0"/>
                 </a:solidFill>
@@ -4829,7 +4710,7 @@
               <a:t> Encryption</a:t>
             </a:r>
             <a:r>
-              <a:rPr lang="en-US" sz="1650" dirty="0" spc="-33" kern="0">
+              <a:rPr lang="en-US" sz="1650" dirty="0" spc="-31" kern="0">
                 <a:solidFill>
                   <a:srgbClr val="9A98A0"/>
                 </a:solidFill>
@@ -4845,14 +4726,14 @@
       </p:sp>
       <p:sp>
         <p:nvSpPr>
-          <p:cNvPr id="27" name="Text 25"/>
-          <p:cNvSpPr/>
-          <p:nvPr/>
-        </p:nvSpPr>
-        <p:spPr>
-          <a:xfrm>
-            <a:off x="5334000" y="6191250"/>
-            <a:ext cx="3429000" cy="666750"/>
+          <p:cNvPr id="26" name="Text 24"/>
+          <p:cNvSpPr/>
+          <p:nvPr/>
+        </p:nvSpPr>
+        <p:spPr>
+          <a:xfrm>
+            <a:off x="6638925" y="4667250"/>
+            <a:ext cx="5000625" cy="647700"/>
           </a:xfrm>
           <a:prstGeom prst="rect">
             <a:avLst/>
@@ -4861,17 +4742,17 @@
           <a:ln/>
         </p:spPr>
         <p:txBody>
-          <a:bodyPr wrap="square" lIns="0" tIns="9716" rIns="0" bIns="-9716" rtlCol="0" anchor="t"/>
+          <a:bodyPr wrap="square" lIns="0" tIns="8906" rIns="0" bIns="-8906" rtlCol="0" anchor="t"/>
           <a:lstStyle/>
           <a:p>
             <a:pPr algn="l" indent="0" marL="0">
               <a:lnSpc>
-                <a:spcPts val="2340"/>
+                <a:spcPts val="2145"/>
               </a:lnSpc>
               <a:buNone/>
             </a:pPr>
             <a:r>
-              <a:rPr lang="en-US" sz="1800" dirty="0" spc="-2" kern="0">
+              <a:rPr lang="en-US" sz="1650" dirty="0" spc="-2" kern="0">
                 <a:solidFill>
                   <a:srgbClr val="D8D3C4"/>
                 </a:solidFill>
@@ -4882,7 +4763,7 @@
               <a:t>khóa</a:t>
             </a:r>
             <a:r>
-              <a:rPr lang="en-US" sz="1800" dirty="0" spc="-1" kern="0">
+              <a:rPr lang="en-US" sz="1650" dirty="0" spc="6" kern="0">
                 <a:solidFill>
                   <a:srgbClr val="D8D3C4"/>
                 </a:solidFill>
@@ -4890,10 +4771,10 @@
                 <a:ea typeface="Be Vietnam Pro" pitchFamily="34" charset="-122"/>
                 <a:cs typeface="Be Vietnam Pro" pitchFamily="34" charset="-120"/>
               </a:rPr>
-              <a:t> mã hóa DEK,</a:t>
-            </a:r>
-            <a:r>
-              <a:rPr lang="en-US" sz="1800" dirty="0" spc="-8" kern="0">
+              <a:t> trực</a:t>
+            </a:r>
+            <a:r>
+              <a:rPr lang="en-US" sz="1650" dirty="0" spc="3" kern="0">
                 <a:solidFill>
                   <a:srgbClr val="D8D3C4"/>
                 </a:solidFill>
@@ -4901,10 +4782,10 @@
                 <a:ea typeface="Be Vietnam Pro" pitchFamily="34" charset="-122"/>
                 <a:cs typeface="Be Vietnam Pro" pitchFamily="34" charset="-120"/>
               </a:rPr>
-              <a:t> cất</a:t>
-            </a:r>
-            <a:r>
-              <a:rPr lang="en-US" sz="1800" dirty="0" spc="-1" kern="0">
+              <a:t> tiếp</a:t>
+            </a:r>
+            <a:r>
+              <a:rPr lang="en-US" sz="1650" dirty="0" spc="2" kern="0">
                 <a:solidFill>
                   <a:srgbClr val="D8D3C4"/>
                 </a:solidFill>
@@ -4912,10 +4793,10 @@
                 <a:ea typeface="Be Vietnam Pro" pitchFamily="34" charset="-122"/>
                 <a:cs typeface="Be Vietnam Pro" pitchFamily="34" charset="-120"/>
               </a:rPr>
-              <a:t> ở</a:t>
-            </a:r>
-            <a:r>
-              <a:rPr lang="en-US" sz="1800" dirty="0" spc="1" kern="0">
+              <a:t> mã</a:t>
+            </a:r>
+            <a:r>
+              <a:rPr lang="en-US" sz="1650" dirty="0" spc="-2" kern="0">
                 <a:solidFill>
                   <a:srgbClr val="D8D3C4"/>
                 </a:solidFill>
@@ -4923,26 +4804,48 @@
                 <a:ea typeface="Be Vietnam Pro" pitchFamily="34" charset="-122"/>
                 <a:cs typeface="Be Vietnam Pro" pitchFamily="34" charset="-120"/>
               </a:rPr>
-              <a:t> chỗ khác</a:t>
-            </a:r>
-            <a:endParaRPr lang="en-US" sz="1800" dirty="0"/>
+              <a:t> hóa</a:t>
+            </a:r>
+            <a:r>
+              <a:rPr lang="en-US" sz="1650" dirty="0" spc="2" kern="0">
+                <a:solidFill>
+                  <a:srgbClr val="D8D3C4"/>
+                </a:solidFill>
+                <a:latin typeface="Be Vietnam Pro" pitchFamily="34" charset="0"/>
+                <a:ea typeface="Be Vietnam Pro" pitchFamily="34" charset="-122"/>
+                <a:cs typeface="Be Vietnam Pro" pitchFamily="34" charset="-120"/>
+              </a:rPr>
+              <a:t> dữ</a:t>
+            </a:r>
+            <a:r>
+              <a:rPr lang="en-US" sz="1650" dirty="0" spc="0" kern="0">
+                <a:solidFill>
+                  <a:srgbClr val="D8D3C4"/>
+                </a:solidFill>
+                <a:latin typeface="Be Vietnam Pro" pitchFamily="34" charset="0"/>
+                <a:ea typeface="Be Vietnam Pro" pitchFamily="34" charset="-122"/>
+                <a:cs typeface="Be Vietnam Pro" pitchFamily="34" charset="-120"/>
+              </a:rPr>
+              <a:t> liệu</a:t>
+            </a:r>
+            <a:endParaRPr lang="en-US" sz="1650" dirty="0"/>
           </a:p>
         </p:txBody>
       </p:sp>
       <p:sp>
         <p:nvSpPr>
-          <p:cNvPr id="28" name="Shape 26"/>
-          <p:cNvSpPr/>
-          <p:nvPr/>
-        </p:nvSpPr>
-        <p:spPr>
-          <a:xfrm>
-            <a:off x="9296400" y="4953000"/>
-            <a:ext cx="3886200" cy="2000250"/>
+          <p:cNvPr id="27" name="Shape 25"/>
+          <p:cNvSpPr/>
+          <p:nvPr/>
+        </p:nvSpPr>
+        <p:spPr>
+          <a:xfrm>
+            <a:off x="11991975" y="3505200"/>
+            <a:ext cx="5381625" cy="1866900"/>
           </a:xfrm>
           <a:prstGeom prst="roundRect">
             <a:avLst>
-              <a:gd name="adj" fmla="val 11429"/>
+              <a:gd name="adj" fmla="val 11224"/>
             </a:avLst>
           </a:prstGeom>
           <a:solidFill>
@@ -4958,14 +4861,14 @@
       </p:sp>
       <p:sp>
         <p:nvSpPr>
-          <p:cNvPr id="29" name="Text 27"/>
-          <p:cNvSpPr/>
-          <p:nvPr/>
-        </p:nvSpPr>
-        <p:spPr>
-          <a:xfrm>
-            <a:off x="9525000" y="5124450"/>
-            <a:ext cx="3429000" cy="666750"/>
+          <p:cNvPr id="28" name="Text 26"/>
+          <p:cNvSpPr/>
+          <p:nvPr/>
+        </p:nvSpPr>
+        <p:spPr>
+          <a:xfrm>
+            <a:off x="12182475" y="3829050"/>
+            <a:ext cx="5000625" cy="438150"/>
           </a:xfrm>
           <a:prstGeom prst="rect">
             <a:avLst/>
@@ -4981,30 +4884,30 @@
               <a:buNone/>
             </a:pPr>
             <a:r>
-              <a:rPr lang="en-US" sz="3900" dirty="0" spc="-56" kern="0">
-                <a:solidFill>
-                  <a:srgbClr val="7C93FF"/>
+              <a:rPr lang="en-US" sz="2550" dirty="0" spc="1" kern="0">
+                <a:solidFill>
+                  <a:srgbClr val="FFB454"/>
                 </a:solidFill>
                 <a:latin typeface="Bricolage Grotesque ExtraBold" pitchFamily="34" charset="0"/>
                 <a:ea typeface="Bricolage Grotesque ExtraBold" pitchFamily="34" charset="-122"/>
                 <a:cs typeface="Bricolage Grotesque ExtraBold" pitchFamily="34" charset="-120"/>
               </a:rPr>
-              <a:t>RBAC</a:t>
-            </a:r>
-            <a:endParaRPr lang="en-US" sz="3900" dirty="0"/>
+              <a:t>KEK</a:t>
+            </a:r>
+            <a:endParaRPr lang="en-US" sz="2550" dirty="0"/>
           </a:p>
         </p:txBody>
       </p:sp>
       <p:sp>
         <p:nvSpPr>
-          <p:cNvPr id="30" name="Text 28"/>
-          <p:cNvSpPr/>
-          <p:nvPr/>
-        </p:nvSpPr>
-        <p:spPr>
-          <a:xfrm>
-            <a:off x="9525000" y="5829300"/>
-            <a:ext cx="3486150" cy="304800"/>
+          <p:cNvPr id="29" name="Text 27"/>
+          <p:cNvSpPr/>
+          <p:nvPr/>
+        </p:nvSpPr>
+        <p:spPr>
+          <a:xfrm>
+            <a:off x="12182475" y="4305300"/>
+            <a:ext cx="5000625" cy="304800"/>
           </a:xfrm>
           <a:prstGeom prst="rect">
             <a:avLst/>
@@ -5020,7 +4923,7 @@
               <a:buNone/>
             </a:pPr>
             <a:r>
-              <a:rPr lang="en-US" sz="1650" dirty="0" spc="-12" kern="0">
+              <a:rPr lang="en-US" sz="1650" dirty="0" spc="-44" kern="0">
                 <a:solidFill>
                   <a:srgbClr val="9A98A0"/>
                 </a:solidFill>
@@ -5028,10 +4931,10 @@
                 <a:ea typeface="Be Vietnam Pro SemiBold" pitchFamily="34" charset="-122"/>
                 <a:cs typeface="Be Vietnam Pro SemiBold" pitchFamily="34" charset="-120"/>
               </a:rPr>
-              <a:t>Role-Based</a:t>
-            </a:r>
-            <a:r>
-              <a:rPr lang="en-US" sz="1650" dirty="0" spc="-7" kern="0">
+              <a:t>Key</a:t>
+            </a:r>
+            <a:r>
+              <a:rPr lang="en-US" sz="1650" dirty="0" spc="-1" kern="0">
                 <a:solidFill>
                   <a:srgbClr val="9A98A0"/>
                 </a:solidFill>
@@ -5039,10 +4942,10 @@
                 <a:ea typeface="Be Vietnam Pro SemiBold" pitchFamily="34" charset="-122"/>
                 <a:cs typeface="Be Vietnam Pro SemiBold" pitchFamily="34" charset="-120"/>
               </a:rPr>
-              <a:t> Access</a:t>
-            </a:r>
-            <a:r>
-              <a:rPr lang="en-US" sz="1650" dirty="0" spc="-10" kern="0">
+              <a:t> Encryption</a:t>
+            </a:r>
+            <a:r>
+              <a:rPr lang="en-US" sz="1650" dirty="0" spc="-33" kern="0">
                 <a:solidFill>
                   <a:srgbClr val="9A98A0"/>
                 </a:solidFill>
@@ -5050,7 +4953,7 @@
                 <a:ea typeface="Be Vietnam Pro SemiBold" pitchFamily="34" charset="-122"/>
                 <a:cs typeface="Be Vietnam Pro SemiBold" pitchFamily="34" charset="-120"/>
               </a:rPr>
-              <a:t> Control</a:t>
+              <a:t> Key</a:t>
             </a:r>
             <a:endParaRPr lang="en-US" sz="1650" dirty="0"/>
           </a:p>
@@ -5058,14 +4961,14 @@
       </p:sp>
       <p:sp>
         <p:nvSpPr>
-          <p:cNvPr id="31" name="Text 29"/>
-          <p:cNvSpPr/>
-          <p:nvPr/>
-        </p:nvSpPr>
-        <p:spPr>
-          <a:xfrm>
-            <a:off x="9525000" y="6191250"/>
-            <a:ext cx="3429000" cy="666750"/>
+          <p:cNvPr id="30" name="Text 28"/>
+          <p:cNvSpPr/>
+          <p:nvPr/>
+        </p:nvSpPr>
+        <p:spPr>
+          <a:xfrm>
+            <a:off x="12182475" y="4667250"/>
+            <a:ext cx="5000625" cy="647700"/>
           </a:xfrm>
           <a:prstGeom prst="rect">
             <a:avLst/>
@@ -5074,17 +4977,17 @@
           <a:ln/>
         </p:spPr>
         <p:txBody>
-          <a:bodyPr wrap="square" lIns="0" tIns="9716" rIns="0" bIns="-9716" rtlCol="0" anchor="t"/>
+          <a:bodyPr wrap="square" lIns="0" tIns="8906" rIns="0" bIns="-8906" rtlCol="0" anchor="t"/>
           <a:lstStyle/>
           <a:p>
             <a:pPr algn="l" indent="0" marL="0">
               <a:lnSpc>
-                <a:spcPts val="2340"/>
+                <a:spcPts val="2145"/>
               </a:lnSpc>
               <a:buNone/>
             </a:pPr>
             <a:r>
-              <a:rPr lang="en-US" sz="1800" dirty="0" spc="-16" kern="0">
+              <a:rPr lang="en-US" sz="1650" dirty="0" spc="-2" kern="0">
                 <a:solidFill>
                   <a:srgbClr val="D8D3C4"/>
                 </a:solidFill>
@@ -5092,10 +4995,10 @@
                 <a:ea typeface="Be Vietnam Pro" pitchFamily="34" charset="-122"/>
                 <a:cs typeface="Be Vietnam Pro" pitchFamily="34" charset="-120"/>
               </a:rPr>
-              <a:t>quyền</a:t>
-            </a:r>
-            <a:r>
-              <a:rPr lang="en-US" sz="1800" dirty="0" spc="-12" kern="0">
+              <a:t>khóa</a:t>
+            </a:r>
+            <a:r>
+              <a:rPr lang="en-US" sz="1650" dirty="0" spc="2" kern="0">
                 <a:solidFill>
                   <a:srgbClr val="D8D3C4"/>
                 </a:solidFill>
@@ -5103,10 +5006,10 @@
                 <a:ea typeface="Be Vietnam Pro" pitchFamily="34" charset="-122"/>
                 <a:cs typeface="Be Vietnam Pro" pitchFamily="34" charset="-120"/>
               </a:rPr>
-              <a:t> gắn</a:t>
-            </a:r>
-            <a:r>
-              <a:rPr lang="en-US" sz="1800" dirty="0" spc="-9" kern="0">
+              <a:t> mã</a:t>
+            </a:r>
+            <a:r>
+              <a:rPr lang="en-US" sz="1650" dirty="0" spc="-2" kern="0">
                 <a:solidFill>
                   <a:srgbClr val="D8D3C4"/>
                 </a:solidFill>
@@ -5114,10 +5017,10 @@
                 <a:ea typeface="Be Vietnam Pro" pitchFamily="34" charset="-122"/>
                 <a:cs typeface="Be Vietnam Pro" pitchFamily="34" charset="-120"/>
               </a:rPr>
-              <a:t> với</a:t>
-            </a:r>
-            <a:r>
-              <a:rPr lang="en-US" sz="1800" dirty="0" spc="-7" kern="0">
+              <a:t> hóa</a:t>
+            </a:r>
+            <a:r>
+              <a:rPr lang="en-US" sz="1650" dirty="0" spc="0" kern="0">
                 <a:solidFill>
                   <a:srgbClr val="D8D3C4"/>
                 </a:solidFill>
@@ -5125,10 +5028,10 @@
                 <a:ea typeface="Be Vietnam Pro" pitchFamily="34" charset="-122"/>
                 <a:cs typeface="Be Vietnam Pro" pitchFamily="34" charset="-120"/>
               </a:rPr>
-              <a:t> vai</a:t>
-            </a:r>
-            <a:r>
-              <a:rPr lang="en-US" sz="1800" dirty="0" spc="-18" kern="0">
+              <a:t> DEK,</a:t>
+            </a:r>
+            <a:r>
+              <a:rPr lang="en-US" sz="1650" dirty="0" spc="-5" kern="0">
                 <a:solidFill>
                   <a:srgbClr val="D8D3C4"/>
                 </a:solidFill>
@@ -5136,26 +5039,59 @@
                 <a:ea typeface="Be Vietnam Pro" pitchFamily="34" charset="-122"/>
                 <a:cs typeface="Be Vietnam Pro" pitchFamily="34" charset="-120"/>
               </a:rPr>
-              <a:t> trò</a:t>
-            </a:r>
-            <a:endParaRPr lang="en-US" sz="1800" dirty="0"/>
+              <a:t> cất</a:t>
+            </a:r>
+            <a:r>
+              <a:rPr lang="en-US" sz="1650" dirty="0" spc="2" kern="0">
+                <a:solidFill>
+                  <a:srgbClr val="D8D3C4"/>
+                </a:solidFill>
+                <a:latin typeface="Be Vietnam Pro" pitchFamily="34" charset="0"/>
+                <a:ea typeface="Be Vietnam Pro" pitchFamily="34" charset="-122"/>
+                <a:cs typeface="Be Vietnam Pro" pitchFamily="34" charset="-120"/>
+              </a:rPr>
+              <a:t> ở</a:t>
+            </a:r>
+            <a:r>
+              <a:rPr lang="en-US" sz="1650" dirty="0" spc="1" kern="0">
+                <a:solidFill>
+                  <a:srgbClr val="D8D3C4"/>
+                </a:solidFill>
+                <a:latin typeface="Be Vietnam Pro" pitchFamily="34" charset="0"/>
+                <a:ea typeface="Be Vietnam Pro" pitchFamily="34" charset="-122"/>
+                <a:cs typeface="Be Vietnam Pro" pitchFamily="34" charset="-120"/>
+              </a:rPr>
+              <a:t> chỗ</a:t>
+            </a:r>
+            <a:r>
+              <a:rPr lang="en-US" sz="1650" dirty="0" spc="2" kern="0">
+                <a:solidFill>
+                  <a:srgbClr val="D8D3C4"/>
+                </a:solidFill>
+                <a:latin typeface="Be Vietnam Pro" pitchFamily="34" charset="0"/>
+                <a:ea typeface="Be Vietnam Pro" pitchFamily="34" charset="-122"/>
+                <a:cs typeface="Be Vietnam Pro" pitchFamily="34" charset="-120"/>
+              </a:rPr>
+              <a:t> khác</a:t>
+            </a:r>
+            <a:endParaRPr lang="en-US" sz="1650" dirty="0"/>
           </a:p>
         </p:txBody>
       </p:sp>
       <p:sp>
         <p:nvSpPr>
-          <p:cNvPr id="32" name="Shape 30"/>
-          <p:cNvSpPr/>
-          <p:nvPr/>
-        </p:nvSpPr>
-        <p:spPr>
-          <a:xfrm>
-            <a:off x="13487400" y="4953000"/>
-            <a:ext cx="3886200" cy="2000250"/>
+          <p:cNvPr id="31" name="Shape 29"/>
+          <p:cNvSpPr/>
+          <p:nvPr/>
+        </p:nvSpPr>
+        <p:spPr>
+          <a:xfrm>
+            <a:off x="914400" y="5524500"/>
+            <a:ext cx="5381625" cy="1866900"/>
           </a:xfrm>
           <a:prstGeom prst="roundRect">
             <a:avLst>
-              <a:gd name="adj" fmla="val 11429"/>
+              <a:gd name="adj" fmla="val 11224"/>
             </a:avLst>
           </a:prstGeom>
           <a:solidFill>
@@ -5171,14 +5107,14 @@
       </p:sp>
       <p:sp>
         <p:nvSpPr>
-          <p:cNvPr id="33" name="Text 31"/>
-          <p:cNvSpPr/>
-          <p:nvPr/>
-        </p:nvSpPr>
-        <p:spPr>
-          <a:xfrm>
-            <a:off x="13716000" y="5124450"/>
-            <a:ext cx="3429000" cy="666750"/>
+          <p:cNvPr id="32" name="Text 30"/>
+          <p:cNvSpPr/>
+          <p:nvPr/>
+        </p:nvSpPr>
+        <p:spPr>
+          <a:xfrm>
+            <a:off x="1104900" y="5848350"/>
+            <a:ext cx="5000625" cy="438150"/>
           </a:xfrm>
           <a:prstGeom prst="rect">
             <a:avLst/>
@@ -5194,30 +5130,30 @@
               <a:buNone/>
             </a:pPr>
             <a:r>
-              <a:rPr lang="en-US" sz="3900" dirty="0" spc="-5" kern="0">
-                <a:solidFill>
-                  <a:srgbClr val="3DD6A0"/>
+              <a:rPr lang="en-US" sz="2550" dirty="0" spc="-32" kern="0">
+                <a:solidFill>
+                  <a:srgbClr val="7C93FF"/>
                 </a:solidFill>
                 <a:latin typeface="Bricolage Grotesque ExtraBold" pitchFamily="34" charset="0"/>
                 <a:ea typeface="Bricolage Grotesque ExtraBold" pitchFamily="34" charset="-122"/>
                 <a:cs typeface="Bricolage Grotesque ExtraBold" pitchFamily="34" charset="-120"/>
               </a:rPr>
-              <a:t>SHA</a:t>
-            </a:r>
-            <a:endParaRPr lang="en-US" sz="3900" dirty="0"/>
+              <a:t>RBAC</a:t>
+            </a:r>
+            <a:endParaRPr lang="en-US" sz="2550" dirty="0"/>
           </a:p>
         </p:txBody>
       </p:sp>
       <p:sp>
         <p:nvSpPr>
-          <p:cNvPr id="34" name="Text 32"/>
-          <p:cNvSpPr/>
-          <p:nvPr/>
-        </p:nvSpPr>
-        <p:spPr>
-          <a:xfrm>
-            <a:off x="13716000" y="5829300"/>
-            <a:ext cx="3486150" cy="304800"/>
+          <p:cNvPr id="33" name="Text 31"/>
+          <p:cNvSpPr/>
+          <p:nvPr/>
+        </p:nvSpPr>
+        <p:spPr>
+          <a:xfrm>
+            <a:off x="1104900" y="6324600"/>
+            <a:ext cx="5000625" cy="304800"/>
           </a:xfrm>
           <a:prstGeom prst="rect">
             <a:avLst/>
@@ -5233,7 +5169,7 @@
               <a:buNone/>
             </a:pPr>
             <a:r>
-              <a:rPr lang="en-US" sz="1650" dirty="0" spc="-11" kern="0">
+              <a:rPr lang="en-US" sz="1650" dirty="0" spc="-12" kern="0">
                 <a:solidFill>
                   <a:srgbClr val="9A98A0"/>
                 </a:solidFill>
@@ -5241,10 +5177,10 @@
                 <a:ea typeface="Be Vietnam Pro SemiBold" pitchFamily="34" charset="-122"/>
                 <a:cs typeface="Be Vietnam Pro SemiBold" pitchFamily="34" charset="-120"/>
               </a:rPr>
-              <a:t>Secure</a:t>
-            </a:r>
-            <a:r>
-              <a:rPr lang="en-US" sz="1650" dirty="0" spc="-3" kern="0">
+              <a:t>Role-Based</a:t>
+            </a:r>
+            <a:r>
+              <a:rPr lang="en-US" sz="1650" dirty="0" spc="-7" kern="0">
                 <a:solidFill>
                   <a:srgbClr val="9A98A0"/>
                 </a:solidFill>
@@ -5252,10 +5188,10 @@
                 <a:ea typeface="Be Vietnam Pro SemiBold" pitchFamily="34" charset="-122"/>
                 <a:cs typeface="Be Vietnam Pro SemiBold" pitchFamily="34" charset="-120"/>
               </a:rPr>
-              <a:t> Hash</a:t>
-            </a:r>
-            <a:r>
-              <a:rPr lang="en-US" sz="1650" dirty="0" spc="0" kern="0">
+              <a:t> Access</a:t>
+            </a:r>
+            <a:r>
+              <a:rPr lang="en-US" sz="1650" dirty="0" spc="-10" kern="0">
                 <a:solidFill>
                   <a:srgbClr val="9A98A0"/>
                 </a:solidFill>
@@ -5263,7 +5199,7 @@
                 <a:ea typeface="Be Vietnam Pro SemiBold" pitchFamily="34" charset="-122"/>
                 <a:cs typeface="Be Vietnam Pro SemiBold" pitchFamily="34" charset="-120"/>
               </a:rPr>
-              <a:t> Algorithm</a:t>
+              <a:t> Control</a:t>
             </a:r>
             <a:endParaRPr lang="en-US" sz="1650" dirty="0"/>
           </a:p>
@@ -5271,14 +5207,14 @@
       </p:sp>
       <p:sp>
         <p:nvSpPr>
-          <p:cNvPr id="35" name="Text 33"/>
-          <p:cNvSpPr/>
-          <p:nvPr/>
-        </p:nvSpPr>
-        <p:spPr>
-          <a:xfrm>
-            <a:off x="13716000" y="6191250"/>
-            <a:ext cx="3429000" cy="666750"/>
+          <p:cNvPr id="34" name="Text 32"/>
+          <p:cNvSpPr/>
+          <p:nvPr/>
+        </p:nvSpPr>
+        <p:spPr>
+          <a:xfrm>
+            <a:off x="1104900" y="6686550"/>
+            <a:ext cx="5000625" cy="647700"/>
           </a:xfrm>
           <a:prstGeom prst="rect">
             <a:avLst/>
@@ -5287,17 +5223,17 @@
           <a:ln/>
         </p:spPr>
         <p:txBody>
-          <a:bodyPr wrap="square" lIns="0" tIns="9716" rIns="0" bIns="-9716" rtlCol="0" anchor="t"/>
+          <a:bodyPr wrap="square" lIns="0" tIns="8906" rIns="0" bIns="-8906" rtlCol="0" anchor="t"/>
           <a:lstStyle/>
           <a:p>
             <a:pPr algn="l" indent="0" marL="0">
               <a:lnSpc>
-                <a:spcPts val="2340"/>
+                <a:spcPts val="2145"/>
               </a:lnSpc>
               <a:buNone/>
             </a:pPr>
             <a:r>
-              <a:rPr lang="en-US" sz="1800" dirty="0" spc="-1" kern="0">
+              <a:rPr lang="en-US" sz="1650" dirty="0" spc="-12" kern="0">
                 <a:solidFill>
                   <a:srgbClr val="D8D3C4"/>
                 </a:solidFill>
@@ -5305,10 +5241,10 @@
                 <a:ea typeface="Be Vietnam Pro" pitchFamily="34" charset="-122"/>
                 <a:cs typeface="Be Vietnam Pro" pitchFamily="34" charset="-120"/>
               </a:rPr>
-              <a:t>họ</a:t>
-            </a:r>
-            <a:r>
-              <a:rPr lang="en-US" sz="1800" dirty="0" spc="-8" kern="0">
+              <a:t>quyền</a:t>
+            </a:r>
+            <a:r>
+              <a:rPr lang="en-US" sz="1650" dirty="0" spc="-8" kern="0">
                 <a:solidFill>
                   <a:srgbClr val="D8D3C4"/>
                 </a:solidFill>
@@ -5316,10 +5252,10 @@
                 <a:ea typeface="Be Vietnam Pro" pitchFamily="34" charset="-122"/>
                 <a:cs typeface="Be Vietnam Pro" pitchFamily="34" charset="-120"/>
               </a:rPr>
-              <a:t> thuật</a:t>
-            </a:r>
-            <a:r>
-              <a:rPr lang="en-US" sz="1800" dirty="0" spc="-10" kern="0">
+              <a:t> gắn với vai</a:t>
+            </a:r>
+            <a:r>
+              <a:rPr lang="en-US" sz="1650" dirty="0" spc="-14" kern="0">
                 <a:solidFill>
                   <a:srgbClr val="D8D3C4"/>
                 </a:solidFill>
@@ -5327,55 +5263,49 @@
                 <a:ea typeface="Be Vietnam Pro" pitchFamily="34" charset="-122"/>
                 <a:cs typeface="Be Vietnam Pro" pitchFamily="34" charset="-120"/>
               </a:rPr>
-              <a:t> toán</a:t>
-            </a:r>
-            <a:r>
-              <a:rPr lang="en-US" sz="1800" dirty="0" spc="-4" kern="0">
-                <a:solidFill>
-                  <a:srgbClr val="D8D3C4"/>
-                </a:solidFill>
-                <a:latin typeface="Be Vietnam Pro" pitchFamily="34" charset="0"/>
-                <a:ea typeface="Be Vietnam Pro" pitchFamily="34" charset="-122"/>
-                <a:cs typeface="Be Vietnam Pro" pitchFamily="34" charset="-120"/>
-              </a:rPr>
-              <a:t> băm,</a:t>
-            </a:r>
-            <a:r>
-              <a:rPr lang="en-US" sz="1800" dirty="0" spc="-1" kern="0">
-                <a:solidFill>
-                  <a:srgbClr val="D8D3C4"/>
-                </a:solidFill>
-                <a:latin typeface="Be Vietnam Pro" pitchFamily="34" charset="0"/>
-                <a:ea typeface="Be Vietnam Pro" pitchFamily="34" charset="-122"/>
-                <a:cs typeface="Be Vietnam Pro" pitchFamily="34" charset="-120"/>
-              </a:rPr>
-              <a:t> như</a:t>
-            </a:r>
-            <a:r>
-              <a:rPr lang="en-US" sz="1800" dirty="0" spc="0" kern="0">
-                <a:solidFill>
-                  <a:srgbClr val="D8D3C4"/>
-                </a:solidFill>
-                <a:latin typeface="Be Vietnam Pro" pitchFamily="34" charset="0"/>
-                <a:ea typeface="Be Vietnam Pro" pitchFamily="34" charset="-122"/>
-                <a:cs typeface="Be Vietnam Pro" pitchFamily="34" charset="-120"/>
-              </a:rPr>
-              <a:t> SHA-256</a:t>
-            </a:r>
-            <a:endParaRPr lang="en-US" sz="1800" dirty="0"/>
+              <a:t> trò</a:t>
+            </a:r>
+            <a:endParaRPr lang="en-US" sz="1650" dirty="0"/>
           </a:p>
         </p:txBody>
       </p:sp>
       <p:sp>
         <p:nvSpPr>
+          <p:cNvPr id="35" name="Shape 33"/>
+          <p:cNvSpPr/>
+          <p:nvPr/>
+        </p:nvSpPr>
+        <p:spPr>
+          <a:xfrm>
+            <a:off x="6448425" y="5524500"/>
+            <a:ext cx="5381625" cy="1866900"/>
+          </a:xfrm>
+          <a:prstGeom prst="roundRect">
+            <a:avLst>
+              <a:gd name="adj" fmla="val 11224"/>
+            </a:avLst>
+          </a:prstGeom>
+          <a:solidFill>
+            <a:srgbClr val="1E212B"/>
+          </a:solidFill>
+          <a:ln w="19050">
+            <a:solidFill>
+              <a:srgbClr val="2A2D38"/>
+            </a:solidFill>
+            <a:prstDash val="solid"/>
+          </a:ln>
+        </p:spPr>
+      </p:sp>
+      <p:sp>
+        <p:nvSpPr>
           <p:cNvPr id="36" name="Text 34"/>
           <p:cNvSpPr/>
           <p:nvPr/>
         </p:nvSpPr>
         <p:spPr>
           <a:xfrm>
-            <a:off x="914400" y="7315200"/>
-            <a:ext cx="8572500" cy="304800"/>
+            <a:off x="6638925" y="5848350"/>
+            <a:ext cx="5000625" cy="438150"/>
           </a:xfrm>
           <a:prstGeom prst="rect">
             <a:avLst/>
@@ -5391,37 +5321,98 @@
               <a:buNone/>
             </a:pPr>
             <a:r>
-              <a:rPr lang="en-US" sz="1650" b="1" spc="227" kern="0" dirty="0">
-                <a:solidFill>
-                  <a:srgbClr val="3DD6A0"/>
-                </a:solidFill>
-                <a:latin typeface="Be Vietnam Pro" pitchFamily="34" charset="0"/>
-                <a:ea typeface="Be Vietnam Pro" pitchFamily="34" charset="-122"/>
-                <a:cs typeface="Be Vietnam Pro" pitchFamily="34" charset="-120"/>
-              </a:rPr>
-              <a:t>NGUỒN</a:t>
-            </a:r>
-            <a:r>
-              <a:rPr lang="en-US" sz="1650" b="1" spc="229" kern="0" dirty="0">
-                <a:solidFill>
-                  <a:srgbClr val="3DD6A0"/>
-                </a:solidFill>
-                <a:latin typeface="Be Vietnam Pro" pitchFamily="34" charset="0"/>
-                <a:ea typeface="Be Vietnam Pro" pitchFamily="34" charset="-122"/>
-                <a:cs typeface="Be Vietnam Pro" pitchFamily="34" charset="-120"/>
-              </a:rPr>
-              <a:t> ĐỐI</a:t>
-            </a:r>
-            <a:r>
-              <a:rPr lang="en-US" sz="1650" b="1" spc="227" kern="0" dirty="0">
-                <a:solidFill>
-                  <a:srgbClr val="3DD6A0"/>
-                </a:solidFill>
-                <a:latin typeface="Be Vietnam Pro" pitchFamily="34" charset="0"/>
-                <a:ea typeface="Be Vietnam Pro" pitchFamily="34" charset="-122"/>
-                <a:cs typeface="Be Vietnam Pro" pitchFamily="34" charset="-120"/>
-              </a:rPr>
-              <a:t> CHIẾU</a:t>
+              <a:rPr lang="en-US" sz="2550" dirty="0" spc="-62" kern="0">
+                <a:solidFill>
+                  <a:srgbClr val="F3EEE3"/>
+                </a:solidFill>
+                <a:latin typeface="Bricolage Grotesque ExtraBold" pitchFamily="34" charset="0"/>
+                <a:ea typeface="Bricolage Grotesque ExtraBold" pitchFamily="34" charset="-122"/>
+                <a:cs typeface="Bricolage Grotesque ExtraBold" pitchFamily="34" charset="-120"/>
+              </a:rPr>
+              <a:t>OWASP</a:t>
+            </a:r>
+            <a:endParaRPr lang="en-US" sz="2550" dirty="0"/>
+          </a:p>
+        </p:txBody>
+      </p:sp>
+      <p:sp>
+        <p:nvSpPr>
+          <p:cNvPr id="37" name="Text 35"/>
+          <p:cNvSpPr/>
+          <p:nvPr/>
+        </p:nvSpPr>
+        <p:spPr>
+          <a:xfrm>
+            <a:off x="6638925" y="6324600"/>
+            <a:ext cx="5000625" cy="304800"/>
+          </a:xfrm>
+          <a:prstGeom prst="rect">
+            <a:avLst/>
+          </a:prstGeom>
+          <a:noFill/>
+          <a:ln/>
+        </p:spPr>
+        <p:txBody>
+          <a:bodyPr wrap="square" lIns="0" tIns="0" rIns="0" bIns="0" rtlCol="0" anchor="t"/>
+          <a:lstStyle/>
+          <a:p>
+            <a:pPr algn="l" indent="0" marL="0">
+              <a:buNone/>
+            </a:pPr>
+            <a:r>
+              <a:rPr lang="en-US" sz="1650" dirty="0" spc="-3" kern="0">
+                <a:solidFill>
+                  <a:srgbClr val="9A98A0"/>
+                </a:solidFill>
+                <a:latin typeface="Be Vietnam Pro SemiBold" pitchFamily="34" charset="0"/>
+                <a:ea typeface="Be Vietnam Pro SemiBold" pitchFamily="34" charset="-122"/>
+                <a:cs typeface="Be Vietnam Pro SemiBold" pitchFamily="34" charset="-120"/>
+              </a:rPr>
+              <a:t>Open</a:t>
+            </a:r>
+            <a:r>
+              <a:rPr lang="en-US" sz="1650" dirty="0" spc="-10" kern="0">
+                <a:solidFill>
+                  <a:srgbClr val="9A98A0"/>
+                </a:solidFill>
+                <a:latin typeface="Be Vietnam Pro SemiBold" pitchFamily="34" charset="0"/>
+                <a:ea typeface="Be Vietnam Pro SemiBold" pitchFamily="34" charset="-122"/>
+                <a:cs typeface="Be Vietnam Pro SemiBold" pitchFamily="34" charset="-120"/>
+              </a:rPr>
+              <a:t> Worldwide</a:t>
+            </a:r>
+            <a:r>
+              <a:rPr lang="en-US" sz="1650" dirty="0" spc="-3" kern="0">
+                <a:solidFill>
+                  <a:srgbClr val="9A98A0"/>
+                </a:solidFill>
+                <a:latin typeface="Be Vietnam Pro SemiBold" pitchFamily="34" charset="0"/>
+                <a:ea typeface="Be Vietnam Pro SemiBold" pitchFamily="34" charset="-122"/>
+                <a:cs typeface="Be Vietnam Pro SemiBold" pitchFamily="34" charset="-120"/>
+              </a:rPr>
+              <a:t> Application</a:t>
+            </a:r>
+            <a:r>
+              <a:rPr lang="en-US" sz="1650" dirty="0" spc="0" kern="0">
+                <a:solidFill>
+                  <a:srgbClr val="9A98A0"/>
+                </a:solidFill>
+                <a:latin typeface="Be Vietnam Pro SemiBold" pitchFamily="34" charset="0"/>
+                <a:ea typeface="Be Vietnam Pro SemiBold" pitchFamily="34" charset="-122"/>
+                <a:cs typeface="Be Vietnam Pro SemiBold" pitchFamily="34" charset="-120"/>
+              </a:rPr>
+              <a:t> Security</a:t>
+            </a:r>
+            <a:r>
+              <a:rPr lang="en-US" sz="1650" dirty="0" spc="-12" kern="0">
+                <a:solidFill>
+                  <a:srgbClr val="9A98A0"/>
+                </a:solidFill>
+                <a:latin typeface="Be Vietnam Pro SemiBold" pitchFamily="34" charset="0"/>
+                <a:ea typeface="Be Vietnam Pro SemiBold" pitchFamily="34" charset="-122"/>
+                <a:cs typeface="Be Vietnam Pro SemiBold" pitchFamily="34" charset="-120"/>
+              </a:rPr>
+              <a:t> Project</a:t>
             </a:r>
             <a:endParaRPr lang="en-US" sz="1650" dirty="0"/>
           </a:p>
@@ -5429,14 +5420,14 @@
       </p:sp>
       <p:sp>
         <p:nvSpPr>
-          <p:cNvPr id="37" name="Text 35"/>
-          <p:cNvSpPr/>
-          <p:nvPr/>
-        </p:nvSpPr>
-        <p:spPr>
-          <a:xfrm>
-            <a:off x="914400" y="7696200"/>
-            <a:ext cx="16459200" cy="800100"/>
+          <p:cNvPr id="38" name="Text 36"/>
+          <p:cNvSpPr/>
+          <p:nvPr/>
+        </p:nvSpPr>
+        <p:spPr>
+          <a:xfrm>
+            <a:off x="6638925" y="6686550"/>
+            <a:ext cx="5000625" cy="647700"/>
           </a:xfrm>
           <a:prstGeom prst="rect">
             <a:avLst/>
@@ -5445,17 +5436,17 @@
           <a:ln/>
         </p:spPr>
         <p:txBody>
-          <a:bodyPr wrap="square" lIns="0" tIns="8001" rIns="0" bIns="-8001" rtlCol="0" anchor="t"/>
+          <a:bodyPr wrap="square" lIns="0" tIns="8906" rIns="0" bIns="-8906" rtlCol="0" anchor="t"/>
           <a:lstStyle/>
           <a:p>
             <a:pPr algn="l" indent="0" marL="0">
               <a:lnSpc>
-                <a:spcPts val="2835"/>
+                <a:spcPts val="2145"/>
               </a:lnSpc>
               <a:buNone/>
             </a:pPr>
             <a:r>
-              <a:rPr lang="en-US" sz="2100" dirty="0" spc="-57" kern="0">
+              <a:rPr lang="en-US" sz="1650" dirty="0" spc="-13" kern="0">
                 <a:solidFill>
                   <a:srgbClr val="D8D3C4"/>
                 </a:solidFill>
@@ -5463,10 +5454,10 @@
                 <a:ea typeface="Be Vietnam Pro" pitchFamily="34" charset="-122"/>
                 <a:cs typeface="Be Vietnam Pro" pitchFamily="34" charset="-120"/>
               </a:rPr>
-              <a:t>OWASP</a:t>
-            </a:r>
-            <a:r>
-              <a:rPr lang="en-US" sz="2100" dirty="0" spc="-11" kern="0">
+              <a:t>tổ</a:t>
+            </a:r>
+            <a:r>
+              <a:rPr lang="en-US" sz="1650" dirty="0" spc="5" kern="0">
                 <a:solidFill>
                   <a:srgbClr val="D8D3C4"/>
                 </a:solidFill>
@@ -5474,10 +5465,10 @@
                 <a:ea typeface="Be Vietnam Pro" pitchFamily="34" charset="-122"/>
                 <a:cs typeface="Be Vietnam Pro" pitchFamily="34" charset="-120"/>
               </a:rPr>
-              <a:t> cheat</a:t>
-            </a:r>
-            <a:r>
-              <a:rPr lang="en-US" sz="2100" dirty="0" spc="-5" kern="0">
+              <a:t> chức</a:t>
+            </a:r>
+            <a:r>
+              <a:rPr lang="en-US" sz="1650" dirty="0" spc="0" kern="0">
                 <a:solidFill>
                   <a:srgbClr val="D8D3C4"/>
                 </a:solidFill>
@@ -5485,10 +5476,10 @@
                 <a:ea typeface="Be Vietnam Pro" pitchFamily="34" charset="-122"/>
                 <a:cs typeface="Be Vietnam Pro" pitchFamily="34" charset="-120"/>
               </a:rPr>
-              <a:t> sheets</a:t>
-            </a:r>
-            <a:r>
-              <a:rPr lang="en-US" sz="2100" dirty="0" spc="-4" kern="0">
+              <a:t> cộng</a:t>
+            </a:r>
+            <a:r>
+              <a:rPr lang="en-US" sz="1650" dirty="0" spc="7" kern="0">
                 <a:solidFill>
                   <a:srgbClr val="D8D3C4"/>
                 </a:solidFill>
@@ -5496,10 +5487,10 @@
                 <a:ea typeface="Be Vietnam Pro" pitchFamily="34" charset="-122"/>
                 <a:cs typeface="Be Vietnam Pro" pitchFamily="34" charset="-120"/>
               </a:rPr>
-              <a:t> ·</a:t>
-            </a:r>
-            <a:r>
-              <a:rPr lang="en-US" sz="2100" dirty="0" spc="-30" kern="0">
+              <a:t> đồng</a:t>
+            </a:r>
+            <a:r>
+              <a:rPr lang="en-US" sz="1650" dirty="0" spc="0" kern="0">
                 <a:solidFill>
                   <a:srgbClr val="D8D3C4"/>
                 </a:solidFill>
@@ -5507,10 +5498,10 @@
                 <a:ea typeface="Be Vietnam Pro" pitchFamily="34" charset="-122"/>
                 <a:cs typeface="Be Vietnam Pro" pitchFamily="34" charset="-120"/>
               </a:rPr>
-              <a:t> pyca/cryptography</a:t>
-            </a:r>
-            <a:r>
-              <a:rPr lang="en-US" sz="2100" dirty="0" spc="-1" kern="0">
+              <a:t> bảo</a:t>
+            </a:r>
+            <a:r>
+              <a:rPr lang="en-US" sz="1650" dirty="0" spc="-6" kern="0">
                 <a:solidFill>
                   <a:srgbClr val="D8D3C4"/>
                 </a:solidFill>
@@ -5518,10 +5509,10 @@
                 <a:ea typeface="Be Vietnam Pro" pitchFamily="34" charset="-122"/>
                 <a:cs typeface="Be Vietnam Pro" pitchFamily="34" charset="-120"/>
               </a:rPr>
-              <a:t> ·</a:t>
-            </a:r>
-            <a:r>
-              <a:rPr lang="en-US" sz="2100" dirty="0" spc="0" kern="0">
+              <a:t> mật</a:t>
+            </a:r>
+            <a:r>
+              <a:rPr lang="en-US" sz="1650" dirty="0" spc="16" kern="0">
                 <a:solidFill>
                   <a:srgbClr val="D8D3C4"/>
                 </a:solidFill>
@@ -5529,10 +5520,10 @@
                 <a:ea typeface="Be Vietnam Pro" pitchFamily="34" charset="-122"/>
                 <a:cs typeface="Be Vietnam Pro" pitchFamily="34" charset="-120"/>
               </a:rPr>
-              <a:t> HashiCorp</a:t>
-            </a:r>
-            <a:r>
-              <a:rPr lang="en-US" sz="2100" dirty="0" spc="-19" kern="0">
+              <a:t> ứng</a:t>
+            </a:r>
+            <a:r>
+              <a:rPr lang="en-US" sz="1650" dirty="0" spc="0" kern="0">
                 <a:solidFill>
                   <a:srgbClr val="D8D3C4"/>
                 </a:solidFill>
@@ -5540,99 +5531,49 @@
                 <a:ea typeface="Be Vietnam Pro" pitchFamily="34" charset="-122"/>
                 <a:cs typeface="Be Vietnam Pro" pitchFamily="34" charset="-120"/>
               </a:rPr>
-              <a:t> Vault</a:t>
-            </a:r>
-            <a:r>
-              <a:rPr lang="en-US" sz="2100" dirty="0" spc="-3" kern="0">
-                <a:solidFill>
-                  <a:srgbClr val="D8D3C4"/>
-                </a:solidFill>
-                <a:latin typeface="Be Vietnam Pro" pitchFamily="34" charset="0"/>
-                <a:ea typeface="Be Vietnam Pro" pitchFamily="34" charset="-122"/>
-                <a:cs typeface="Be Vietnam Pro" pitchFamily="34" charset="-120"/>
-              </a:rPr>
-              <a:t> docs</a:t>
-            </a:r>
-            <a:r>
-              <a:rPr lang="en-US" sz="2100" dirty="0" spc="-4" kern="0">
-                <a:solidFill>
-                  <a:srgbClr val="D8D3C4"/>
-                </a:solidFill>
-                <a:latin typeface="Be Vietnam Pro" pitchFamily="34" charset="0"/>
-                <a:ea typeface="Be Vietnam Pro" pitchFamily="34" charset="-122"/>
-                <a:cs typeface="Be Vietnam Pro" pitchFamily="34" charset="-120"/>
-              </a:rPr>
-              <a:t> ·</a:t>
-            </a:r>
-            <a:r>
-              <a:rPr lang="en-US" sz="2100" dirty="0" spc="5" kern="0">
-                <a:solidFill>
-                  <a:srgbClr val="D8D3C4"/>
-                </a:solidFill>
-                <a:latin typeface="Be Vietnam Pro" pitchFamily="34" charset="0"/>
-                <a:ea typeface="Be Vietnam Pro" pitchFamily="34" charset="-122"/>
-                <a:cs typeface="Be Vietnam Pro" pitchFamily="34" charset="-120"/>
-              </a:rPr>
-              <a:t> CPython</a:t>
-            </a:r>
-            <a:r>
-              <a:rPr lang="en-US" sz="2100" dirty="0" spc="1" kern="0">
-                <a:solidFill>
-                  <a:srgbClr val="D8D3C4"/>
-                </a:solidFill>
-                <a:latin typeface="Be Vietnam Pro" pitchFamily="34" charset="0"/>
-                <a:ea typeface="Be Vietnam Pro" pitchFamily="34" charset="-122"/>
-                <a:cs typeface="Be Vietnam Pro" pitchFamily="34" charset="-120"/>
-              </a:rPr>
-              <a:t> ssl</a:t>
-            </a:r>
-            <a:r>
-              <a:rPr lang="en-US" sz="2100" dirty="0" spc="-3" kern="0">
-                <a:solidFill>
-                  <a:srgbClr val="D8D3C4"/>
-                </a:solidFill>
-                <a:latin typeface="Be Vietnam Pro" pitchFamily="34" charset="0"/>
-                <a:ea typeface="Be Vietnam Pro" pitchFamily="34" charset="-122"/>
-                <a:cs typeface="Be Vietnam Pro" pitchFamily="34" charset="-120"/>
-              </a:rPr>
-              <a:t> ·</a:t>
-            </a:r>
-            <a:r>
-              <a:rPr lang="en-US" sz="2100" dirty="0" spc="-6" kern="0">
-                <a:solidFill>
-                  <a:srgbClr val="D8D3C4"/>
-                </a:solidFill>
-                <a:latin typeface="Be Vietnam Pro" pitchFamily="34" charset="0"/>
-                <a:ea typeface="Be Vietnam Pro" pitchFamily="34" charset="-122"/>
-                <a:cs typeface="Be Vietnam Pro" pitchFamily="34" charset="-120"/>
-              </a:rPr>
-              <a:t> ByteByteGo</a:t>
-            </a:r>
-            <a:r>
-              <a:rPr lang="en-US" sz="2100" dirty="0" spc="-7" kern="0">
-                <a:solidFill>
-                  <a:srgbClr val="D8D3C4"/>
-                </a:solidFill>
-                <a:latin typeface="Be Vietnam Pro" pitchFamily="34" charset="0"/>
-                <a:ea typeface="Be Vietnam Pro" pitchFamily="34" charset="-122"/>
-                <a:cs typeface="Be Vietnam Pro" pitchFamily="34" charset="-120"/>
-              </a:rPr>
-              <a:t> system-design-101</a:t>
-            </a:r>
-            <a:endParaRPr lang="en-US" sz="2100" dirty="0"/>
+              <a:t> dụng</a:t>
+            </a:r>
+            <a:endParaRPr lang="en-US" sz="1650" dirty="0"/>
           </a:p>
         </p:txBody>
       </p:sp>
       <p:sp>
         <p:nvSpPr>
-          <p:cNvPr id="38" name="Text 36"/>
-          <p:cNvSpPr/>
-          <p:nvPr/>
-        </p:nvSpPr>
-        <p:spPr>
-          <a:xfrm>
-            <a:off x="914400" y="8629650"/>
-            <a:ext cx="14287500" cy="323850"/>
+          <p:cNvPr id="39" name="Shape 37"/>
+          <p:cNvSpPr/>
+          <p:nvPr/>
+        </p:nvSpPr>
+        <p:spPr>
+          <a:xfrm>
+            <a:off x="11991975" y="5524500"/>
+            <a:ext cx="5381625" cy="1866900"/>
+          </a:xfrm>
+          <a:prstGeom prst="roundRect">
+            <a:avLst>
+              <a:gd name="adj" fmla="val 11224"/>
+            </a:avLst>
+          </a:prstGeom>
+          <a:solidFill>
+            <a:srgbClr val="1E212B"/>
+          </a:solidFill>
+          <a:ln w="19050">
+            <a:solidFill>
+              <a:srgbClr val="2A2D38"/>
+            </a:solidFill>
+            <a:prstDash val="solid"/>
+          </a:ln>
+        </p:spPr>
+      </p:sp>
+      <p:sp>
+        <p:nvSpPr>
+          <p:cNvPr id="40" name="Text 38"/>
+          <p:cNvSpPr/>
+          <p:nvPr/>
+        </p:nvSpPr>
+        <p:spPr>
+          <a:xfrm>
+            <a:off x="12182475" y="5848350"/>
+            <a:ext cx="5000625" cy="438150"/>
           </a:xfrm>
           <a:prstGeom prst="rect">
             <a:avLst/>
@@ -5648,10 +5589,461 @@
               <a:buNone/>
             </a:pPr>
             <a:r>
-              <a:rPr lang="en-US" sz="1800" dirty="0" spc="3" kern="0">
+              <a:rPr lang="en-US" sz="2550" dirty="0" spc="3" kern="0">
+                <a:solidFill>
+                  <a:srgbClr val="3DD6A0"/>
+                </a:solidFill>
+                <a:latin typeface="Bricolage Grotesque ExtraBold" pitchFamily="34" charset="0"/>
+                <a:ea typeface="Bricolage Grotesque ExtraBold" pitchFamily="34" charset="-122"/>
+                <a:cs typeface="Bricolage Grotesque ExtraBold" pitchFamily="34" charset="-120"/>
+              </a:rPr>
+              <a:t>SHA</a:t>
+            </a:r>
+            <a:endParaRPr lang="en-US" sz="2550" dirty="0"/>
+          </a:p>
+        </p:txBody>
+      </p:sp>
+      <p:sp>
+        <p:nvSpPr>
+          <p:cNvPr id="41" name="Text 39"/>
+          <p:cNvSpPr/>
+          <p:nvPr/>
+        </p:nvSpPr>
+        <p:spPr>
+          <a:xfrm>
+            <a:off x="12182475" y="6324600"/>
+            <a:ext cx="5000625" cy="304800"/>
+          </a:xfrm>
+          <a:prstGeom prst="rect">
+            <a:avLst/>
+          </a:prstGeom>
+          <a:noFill/>
+          <a:ln/>
+        </p:spPr>
+        <p:txBody>
+          <a:bodyPr wrap="square" lIns="0" tIns="0" rIns="0" bIns="0" rtlCol="0" anchor="t"/>
+          <a:lstStyle/>
+          <a:p>
+            <a:pPr algn="l" indent="0" marL="0">
+              <a:buNone/>
+            </a:pPr>
+            <a:r>
+              <a:rPr lang="en-US" sz="1650" dirty="0" spc="-11" kern="0">
                 <a:solidFill>
                   <a:srgbClr val="9A98A0"/>
                 </a:solidFill>
+                <a:latin typeface="Be Vietnam Pro SemiBold" pitchFamily="34" charset="0"/>
+                <a:ea typeface="Be Vietnam Pro SemiBold" pitchFamily="34" charset="-122"/>
+                <a:cs typeface="Be Vietnam Pro SemiBold" pitchFamily="34" charset="-120"/>
+              </a:rPr>
+              <a:t>Secure</a:t>
+            </a:r>
+            <a:r>
+              <a:rPr lang="en-US" sz="1650" dirty="0" spc="-3" kern="0">
+                <a:solidFill>
+                  <a:srgbClr val="9A98A0"/>
+                </a:solidFill>
+                <a:latin typeface="Be Vietnam Pro SemiBold" pitchFamily="34" charset="0"/>
+                <a:ea typeface="Be Vietnam Pro SemiBold" pitchFamily="34" charset="-122"/>
+                <a:cs typeface="Be Vietnam Pro SemiBold" pitchFamily="34" charset="-120"/>
+              </a:rPr>
+              <a:t> Hash</a:t>
+            </a:r>
+            <a:r>
+              <a:rPr lang="en-US" sz="1650" dirty="0" spc="0" kern="0">
+                <a:solidFill>
+                  <a:srgbClr val="9A98A0"/>
+                </a:solidFill>
+                <a:latin typeface="Be Vietnam Pro SemiBold" pitchFamily="34" charset="0"/>
+                <a:ea typeface="Be Vietnam Pro SemiBold" pitchFamily="34" charset="-122"/>
+                <a:cs typeface="Be Vietnam Pro SemiBold" pitchFamily="34" charset="-120"/>
+              </a:rPr>
+              <a:t> Algorithm</a:t>
+            </a:r>
+            <a:endParaRPr lang="en-US" sz="1650" dirty="0"/>
+          </a:p>
+        </p:txBody>
+      </p:sp>
+      <p:sp>
+        <p:nvSpPr>
+          <p:cNvPr id="42" name="Text 40"/>
+          <p:cNvSpPr/>
+          <p:nvPr/>
+        </p:nvSpPr>
+        <p:spPr>
+          <a:xfrm>
+            <a:off x="12182475" y="6686550"/>
+            <a:ext cx="5000625" cy="647700"/>
+          </a:xfrm>
+          <a:prstGeom prst="rect">
+            <a:avLst/>
+          </a:prstGeom>
+          <a:noFill/>
+          <a:ln/>
+        </p:spPr>
+        <p:txBody>
+          <a:bodyPr wrap="square" lIns="0" tIns="8906" rIns="0" bIns="-8906" rtlCol="0" anchor="t"/>
+          <a:lstStyle/>
+          <a:p>
+            <a:pPr algn="l" indent="0" marL="0">
+              <a:lnSpc>
+                <a:spcPts val="2145"/>
+              </a:lnSpc>
+              <a:buNone/>
+            </a:pPr>
+            <a:r>
+              <a:rPr lang="en-US" sz="1650" dirty="0" spc="0" kern="0">
+                <a:solidFill>
+                  <a:srgbClr val="D8D3C4"/>
+                </a:solidFill>
+                <a:latin typeface="Be Vietnam Pro" pitchFamily="34" charset="0"/>
+                <a:ea typeface="Be Vietnam Pro" pitchFamily="34" charset="-122"/>
+                <a:cs typeface="Be Vietnam Pro" pitchFamily="34" charset="-120"/>
+              </a:rPr>
+              <a:t>họ</a:t>
+            </a:r>
+            <a:r>
+              <a:rPr lang="en-US" sz="1650" dirty="0" spc="-3" kern="0">
+                <a:solidFill>
+                  <a:srgbClr val="D8D3C4"/>
+                </a:solidFill>
+                <a:latin typeface="Be Vietnam Pro" pitchFamily="34" charset="0"/>
+                <a:ea typeface="Be Vietnam Pro" pitchFamily="34" charset="-122"/>
+                <a:cs typeface="Be Vietnam Pro" pitchFamily="34" charset="-120"/>
+              </a:rPr>
+              <a:t> thuật</a:t>
+            </a:r>
+            <a:r>
+              <a:rPr lang="en-US" sz="1650" dirty="0" spc="-7" kern="0">
+                <a:solidFill>
+                  <a:srgbClr val="D8D3C4"/>
+                </a:solidFill>
+                <a:latin typeface="Be Vietnam Pro" pitchFamily="34" charset="0"/>
+                <a:ea typeface="Be Vietnam Pro" pitchFamily="34" charset="-122"/>
+                <a:cs typeface="Be Vietnam Pro" pitchFamily="34" charset="-120"/>
+              </a:rPr>
+              <a:t> toán</a:t>
+            </a:r>
+            <a:r>
+              <a:rPr lang="en-US" sz="1650" dirty="0" spc="-1" kern="0">
+                <a:solidFill>
+                  <a:srgbClr val="D8D3C4"/>
+                </a:solidFill>
+                <a:latin typeface="Be Vietnam Pro" pitchFamily="34" charset="0"/>
+                <a:ea typeface="Be Vietnam Pro" pitchFamily="34" charset="-122"/>
+                <a:cs typeface="Be Vietnam Pro" pitchFamily="34" charset="-120"/>
+              </a:rPr>
+              <a:t> băm,</a:t>
+            </a:r>
+            <a:r>
+              <a:rPr lang="en-US" sz="1650" dirty="0" spc="1" kern="0">
+                <a:solidFill>
+                  <a:srgbClr val="D8D3C4"/>
+                </a:solidFill>
+                <a:latin typeface="Be Vietnam Pro" pitchFamily="34" charset="0"/>
+                <a:ea typeface="Be Vietnam Pro" pitchFamily="34" charset="-122"/>
+                <a:cs typeface="Be Vietnam Pro" pitchFamily="34" charset="-120"/>
+              </a:rPr>
+              <a:t> như</a:t>
+            </a:r>
+            <a:r>
+              <a:rPr lang="en-US" sz="1650" dirty="0" spc="0" kern="0">
+                <a:solidFill>
+                  <a:srgbClr val="D8D3C4"/>
+                </a:solidFill>
+                <a:latin typeface="Be Vietnam Pro" pitchFamily="34" charset="0"/>
+                <a:ea typeface="Be Vietnam Pro" pitchFamily="34" charset="-122"/>
+                <a:cs typeface="Be Vietnam Pro" pitchFamily="34" charset="-120"/>
+              </a:rPr>
+              <a:t> SHA-256</a:t>
+            </a:r>
+            <a:endParaRPr lang="en-US" sz="1650" dirty="0"/>
+          </a:p>
+        </p:txBody>
+      </p:sp>
+      <p:sp>
+        <p:nvSpPr>
+          <p:cNvPr id="43" name="Text 41"/>
+          <p:cNvSpPr/>
+          <p:nvPr/>
+        </p:nvSpPr>
+        <p:spPr>
+          <a:xfrm>
+            <a:off x="914400" y="7867650"/>
+            <a:ext cx="8572500" cy="304800"/>
+          </a:xfrm>
+          <a:prstGeom prst="rect">
+            <a:avLst/>
+          </a:prstGeom>
+          <a:noFill/>
+          <a:ln/>
+        </p:spPr>
+        <p:txBody>
+          <a:bodyPr wrap="square" lIns="0" tIns="0" rIns="0" bIns="0" rtlCol="0" anchor="t"/>
+          <a:lstStyle/>
+          <a:p>
+            <a:pPr algn="l" indent="0" marL="0">
+              <a:buNone/>
+            </a:pPr>
+            <a:r>
+              <a:rPr lang="en-US" sz="1650" b="1" spc="227" kern="0" dirty="0">
+                <a:solidFill>
+                  <a:srgbClr val="3DD6A0"/>
+                </a:solidFill>
+                <a:latin typeface="Be Vietnam Pro" pitchFamily="34" charset="0"/>
+                <a:ea typeface="Be Vietnam Pro" pitchFamily="34" charset="-122"/>
+                <a:cs typeface="Be Vietnam Pro" pitchFamily="34" charset="-120"/>
+              </a:rPr>
+              <a:t>NGUỒN</a:t>
+            </a:r>
+            <a:r>
+              <a:rPr lang="en-US" sz="1650" b="1" spc="229" kern="0" dirty="0">
+                <a:solidFill>
+                  <a:srgbClr val="3DD6A0"/>
+                </a:solidFill>
+                <a:latin typeface="Be Vietnam Pro" pitchFamily="34" charset="0"/>
+                <a:ea typeface="Be Vietnam Pro" pitchFamily="34" charset="-122"/>
+                <a:cs typeface="Be Vietnam Pro" pitchFamily="34" charset="-120"/>
+              </a:rPr>
+              <a:t> ĐỐI</a:t>
+            </a:r>
+            <a:r>
+              <a:rPr lang="en-US" sz="1650" b="1" spc="227" kern="0" dirty="0">
+                <a:solidFill>
+                  <a:srgbClr val="3DD6A0"/>
+                </a:solidFill>
+                <a:latin typeface="Be Vietnam Pro" pitchFamily="34" charset="0"/>
+                <a:ea typeface="Be Vietnam Pro" pitchFamily="34" charset="-122"/>
+                <a:cs typeface="Be Vietnam Pro" pitchFamily="34" charset="-120"/>
+              </a:rPr>
+              <a:t> CHIẾU</a:t>
+            </a:r>
+            <a:endParaRPr lang="en-US" sz="1650" dirty="0"/>
+          </a:p>
+        </p:txBody>
+      </p:sp>
+      <p:sp>
+        <p:nvSpPr>
+          <p:cNvPr id="44" name="Text 42"/>
+          <p:cNvSpPr/>
+          <p:nvPr/>
+        </p:nvSpPr>
+        <p:spPr>
+          <a:xfrm>
+            <a:off x="914400" y="8248650"/>
+            <a:ext cx="16459200" cy="381000"/>
+          </a:xfrm>
+          <a:prstGeom prst="rect">
+            <a:avLst/>
+          </a:prstGeom>
+          <a:noFill/>
+          <a:ln/>
+        </p:spPr>
+        <p:txBody>
+          <a:bodyPr wrap="square" lIns="0" tIns="0" rIns="0" bIns="0" rtlCol="0" anchor="t"/>
+          <a:lstStyle/>
+          <a:p>
+            <a:pPr algn="l" indent="0" marL="0">
+              <a:buNone/>
+            </a:pPr>
+            <a:r>
+              <a:rPr lang="en-US" sz="1950" dirty="0" spc="-51" kern="0">
+                <a:solidFill>
+                  <a:srgbClr val="D8D3C4"/>
+                </a:solidFill>
+                <a:latin typeface="Be Vietnam Pro" pitchFamily="34" charset="0"/>
+                <a:ea typeface="Be Vietnam Pro" pitchFamily="34" charset="-122"/>
+                <a:cs typeface="Be Vietnam Pro" pitchFamily="34" charset="-120"/>
+              </a:rPr>
+              <a:t>OWASP</a:t>
+            </a:r>
+            <a:r>
+              <a:rPr lang="en-US" sz="1950" dirty="0" spc="-8" kern="0">
+                <a:solidFill>
+                  <a:srgbClr val="D8D3C4"/>
+                </a:solidFill>
+                <a:latin typeface="Be Vietnam Pro" pitchFamily="34" charset="0"/>
+                <a:ea typeface="Be Vietnam Pro" pitchFamily="34" charset="-122"/>
+                <a:cs typeface="Be Vietnam Pro" pitchFamily="34" charset="-120"/>
+              </a:rPr>
+              <a:t> cheat</a:t>
+            </a:r>
+            <a:r>
+              <a:rPr lang="en-US" sz="1950" dirty="0" spc="-3" kern="0">
+                <a:solidFill>
+                  <a:srgbClr val="D8D3C4"/>
+                </a:solidFill>
+                <a:latin typeface="Be Vietnam Pro" pitchFamily="34" charset="0"/>
+                <a:ea typeface="Be Vietnam Pro" pitchFamily="34" charset="-122"/>
+                <a:cs typeface="Be Vietnam Pro" pitchFamily="34" charset="-120"/>
+              </a:rPr>
+              <a:t> sheets</a:t>
+            </a:r>
+            <a:r>
+              <a:rPr lang="en-US" sz="1950" dirty="0" spc="-1" kern="0">
+                <a:solidFill>
+                  <a:srgbClr val="D8D3C4"/>
+                </a:solidFill>
+                <a:latin typeface="Be Vietnam Pro" pitchFamily="34" charset="0"/>
+                <a:ea typeface="Be Vietnam Pro" pitchFamily="34" charset="-122"/>
+                <a:cs typeface="Be Vietnam Pro" pitchFamily="34" charset="-120"/>
+              </a:rPr>
+              <a:t> ·</a:t>
+            </a:r>
+            <a:r>
+              <a:rPr lang="en-US" sz="1950" dirty="0" spc="-26" kern="0">
+                <a:solidFill>
+                  <a:srgbClr val="D8D3C4"/>
+                </a:solidFill>
+                <a:latin typeface="Be Vietnam Pro" pitchFamily="34" charset="0"/>
+                <a:ea typeface="Be Vietnam Pro" pitchFamily="34" charset="-122"/>
+                <a:cs typeface="Be Vietnam Pro" pitchFamily="34" charset="-120"/>
+              </a:rPr>
+              <a:t> pyca/cryptography</a:t>
+            </a:r>
+            <a:r>
+              <a:rPr lang="en-US" sz="1950" dirty="0" spc="-1" kern="0">
+                <a:solidFill>
+                  <a:srgbClr val="D8D3C4"/>
+                </a:solidFill>
+                <a:latin typeface="Be Vietnam Pro" pitchFamily="34" charset="0"/>
+                <a:ea typeface="Be Vietnam Pro" pitchFamily="34" charset="-122"/>
+                <a:cs typeface="Be Vietnam Pro" pitchFamily="34" charset="-120"/>
+              </a:rPr>
+              <a:t> ·</a:t>
+            </a:r>
+            <a:r>
+              <a:rPr lang="en-US" sz="1950" dirty="0" spc="0" kern="0">
+                <a:solidFill>
+                  <a:srgbClr val="D8D3C4"/>
+                </a:solidFill>
+                <a:latin typeface="Be Vietnam Pro" pitchFamily="34" charset="0"/>
+                <a:ea typeface="Be Vietnam Pro" pitchFamily="34" charset="-122"/>
+                <a:cs typeface="Be Vietnam Pro" pitchFamily="34" charset="-120"/>
+              </a:rPr>
+              <a:t> HashiCorp</a:t>
+            </a:r>
+            <a:r>
+              <a:rPr lang="en-US" sz="1950" dirty="0" spc="-15" kern="0">
+                <a:solidFill>
+                  <a:srgbClr val="D8D3C4"/>
+                </a:solidFill>
+                <a:latin typeface="Be Vietnam Pro" pitchFamily="34" charset="0"/>
+                <a:ea typeface="Be Vietnam Pro" pitchFamily="34" charset="-122"/>
+                <a:cs typeface="Be Vietnam Pro" pitchFamily="34" charset="-120"/>
+              </a:rPr>
+              <a:t> Vault</a:t>
+            </a:r>
+            <a:r>
+              <a:rPr lang="en-US" sz="1950" dirty="0" spc="-3" kern="0">
+                <a:solidFill>
+                  <a:srgbClr val="D8D3C4"/>
+                </a:solidFill>
+                <a:latin typeface="Be Vietnam Pro" pitchFamily="34" charset="0"/>
+                <a:ea typeface="Be Vietnam Pro" pitchFamily="34" charset="-122"/>
+                <a:cs typeface="Be Vietnam Pro" pitchFamily="34" charset="-120"/>
+              </a:rPr>
+              <a:t> docs</a:t>
+            </a:r>
+            <a:r>
+              <a:rPr lang="en-US" sz="1950" dirty="0" spc="-1" kern="0">
+                <a:solidFill>
+                  <a:srgbClr val="D8D3C4"/>
+                </a:solidFill>
+                <a:latin typeface="Be Vietnam Pro" pitchFamily="34" charset="0"/>
+                <a:ea typeface="Be Vietnam Pro" pitchFamily="34" charset="-122"/>
+                <a:cs typeface="Be Vietnam Pro" pitchFamily="34" charset="-120"/>
+              </a:rPr>
+              <a:t> ·</a:t>
+            </a:r>
+            <a:r>
+              <a:rPr lang="en-US" sz="1950" dirty="0" spc="5" kern="0">
+                <a:solidFill>
+                  <a:srgbClr val="D8D3C4"/>
+                </a:solidFill>
+                <a:latin typeface="Be Vietnam Pro" pitchFamily="34" charset="0"/>
+                <a:ea typeface="Be Vietnam Pro" pitchFamily="34" charset="-122"/>
+                <a:cs typeface="Be Vietnam Pro" pitchFamily="34" charset="-120"/>
+              </a:rPr>
+              <a:t> CPython</a:t>
+            </a:r>
+            <a:r>
+              <a:rPr lang="en-US" sz="1950" dirty="0" spc="1" kern="0">
+                <a:solidFill>
+                  <a:srgbClr val="D8D3C4"/>
+                </a:solidFill>
+                <a:latin typeface="Be Vietnam Pro" pitchFamily="34" charset="0"/>
+                <a:ea typeface="Be Vietnam Pro" pitchFamily="34" charset="-122"/>
+                <a:cs typeface="Be Vietnam Pro" pitchFamily="34" charset="-120"/>
+              </a:rPr>
+              <a:t> ssl</a:t>
+            </a:r>
+            <a:r>
+              <a:rPr lang="en-US" sz="1950" dirty="0" spc="-1" kern="0">
+                <a:solidFill>
+                  <a:srgbClr val="D8D3C4"/>
+                </a:solidFill>
+                <a:latin typeface="Be Vietnam Pro" pitchFamily="34" charset="0"/>
+                <a:ea typeface="Be Vietnam Pro" pitchFamily="34" charset="-122"/>
+                <a:cs typeface="Be Vietnam Pro" pitchFamily="34" charset="-120"/>
+              </a:rPr>
+              <a:t> ·</a:t>
+            </a:r>
+            <a:r>
+              <a:rPr lang="en-US" sz="1950" dirty="0" spc="-3" kern="0">
+                <a:solidFill>
+                  <a:srgbClr val="D8D3C4"/>
+                </a:solidFill>
+                <a:latin typeface="Be Vietnam Pro" pitchFamily="34" charset="0"/>
+                <a:ea typeface="Be Vietnam Pro" pitchFamily="34" charset="-122"/>
+                <a:cs typeface="Be Vietnam Pro" pitchFamily="34" charset="-120"/>
+              </a:rPr>
+              <a:t> ByteByteGo</a:t>
+            </a:r>
+            <a:r>
+              <a:rPr lang="en-US" sz="1950" dirty="0" spc="-5" kern="0">
+                <a:solidFill>
+                  <a:srgbClr val="D8D3C4"/>
+                </a:solidFill>
+                <a:latin typeface="Be Vietnam Pro" pitchFamily="34" charset="0"/>
+                <a:ea typeface="Be Vietnam Pro" pitchFamily="34" charset="-122"/>
+                <a:cs typeface="Be Vietnam Pro" pitchFamily="34" charset="-120"/>
+              </a:rPr>
+              <a:t> system-design-101</a:t>
+            </a:r>
+            <a:endParaRPr lang="en-US" sz="1950" dirty="0"/>
+          </a:p>
+        </p:txBody>
+      </p:sp>
+      <p:sp>
+        <p:nvSpPr>
+          <p:cNvPr id="45" name="Text 43"/>
+          <p:cNvSpPr/>
+          <p:nvPr/>
+        </p:nvSpPr>
+        <p:spPr>
+          <a:xfrm>
+            <a:off x="914400" y="8801100"/>
+            <a:ext cx="14287500" cy="304800"/>
+          </a:xfrm>
+          <a:prstGeom prst="rect">
+            <a:avLst/>
+          </a:prstGeom>
+          <a:noFill/>
+          <a:ln/>
+        </p:spPr>
+        <p:txBody>
+          <a:bodyPr wrap="square" lIns="0" tIns="0" rIns="0" bIns="0" rtlCol="0" anchor="t"/>
+          <a:lstStyle/>
+          <a:p>
+            <a:pPr algn="l" indent="0" marL="0">
+              <a:buNone/>
+            </a:pPr>
+            <a:r>
+              <a:rPr lang="en-US" sz="1650" dirty="0" spc="1" kern="0">
+                <a:solidFill>
+                  <a:srgbClr val="9A98A0"/>
+                </a:solidFill>
                 <a:latin typeface="Be Vietnam Pro" pitchFamily="34" charset="0"/>
                 <a:ea typeface="Be Vietnam Pro" pitchFamily="34" charset="-122"/>
                 <a:cs typeface="Be Vietnam Pro" pitchFamily="34" charset="-120"/>
@@ -5659,7 +6051,7 @@
               <a:t>Đã</a:t>
             </a:r>
             <a:r>
-              <a:rPr lang="en-US" sz="1800" dirty="0" spc="10" kern="0">
+              <a:rPr lang="en-US" sz="1650" dirty="0" spc="10" kern="0">
                 <a:solidFill>
                   <a:srgbClr val="9A98A0"/>
                 </a:solidFill>
@@ -5670,7 +6062,7 @@
               <a:t> đối</a:t>
             </a:r>
             <a:r>
-              <a:rPr lang="en-US" sz="1800" dirty="0" spc="-1" kern="0">
+              <a:rPr lang="en-US" sz="1650" dirty="0" spc="1" kern="0">
                 <a:solidFill>
                   <a:srgbClr val="9A98A0"/>
                 </a:solidFill>
@@ -5681,7 +6073,7 @@
               <a:t> chiếu</a:t>
             </a:r>
             <a:r>
-              <a:rPr lang="en-US" sz="1800" dirty="0" spc="-14" kern="0">
+              <a:rPr lang="en-US" sz="1650" dirty="0" spc="-12" kern="0">
                 <a:solidFill>
                   <a:srgbClr val="9A98A0"/>
                 </a:solidFill>
@@ -5692,7 +6084,7 @@
               <a:t> ngày</a:t>
             </a:r>
             <a:r>
-              <a:rPr lang="en-US" sz="1800" dirty="0" spc="1" kern="0">
+              <a:rPr lang="en-US" sz="1650" dirty="0" spc="0" kern="0">
                 <a:solidFill>
                   <a:srgbClr val="9A98A0"/>
                 </a:solidFill>
@@ -5700,10 +6092,10 @@
                 <a:ea typeface="Be Vietnam Pro" pitchFamily="34" charset="-122"/>
                 <a:cs typeface="Be Vietnam Pro" pitchFamily="34" charset="-120"/>
               </a:rPr>
-              <a:t> 2026-10-18.</a:t>
-            </a:r>
-            <a:r>
-              <a:rPr lang="en-US" sz="1800" dirty="0" spc="-2" kern="0">
+              <a:t> 2026-10-18. Hình</a:t>
+            </a:r>
+            <a:r>
+              <a:rPr lang="en-US" sz="1650" dirty="0" spc="-1" kern="0">
                 <a:solidFill>
                   <a:srgbClr val="9A98A0"/>
                 </a:solidFill>
@@ -5711,10 +6103,10 @@
                 <a:ea typeface="Be Vietnam Pro" pitchFamily="34" charset="-122"/>
                 <a:cs typeface="Be Vietnam Pro" pitchFamily="34" charset="-120"/>
               </a:rPr>
-              <a:t> Hình</a:t>
-            </a:r>
-            <a:r>
-              <a:rPr lang="en-US" sz="1800" dirty="0" spc="-3" kern="0">
+              <a:t> minh họa</a:t>
+            </a:r>
+            <a:r>
+              <a:rPr lang="en-US" sz="1650" dirty="0" spc="1" kern="0">
                 <a:solidFill>
                   <a:srgbClr val="9A98A0"/>
                 </a:solidFill>
@@ -5722,10 +6114,10 @@
                 <a:ea typeface="Be Vietnam Pro" pitchFamily="34" charset="-122"/>
                 <a:cs typeface="Be Vietnam Pro" pitchFamily="34" charset="-120"/>
               </a:rPr>
-              <a:t> minh</a:t>
-            </a:r>
-            <a:r>
-              <a:rPr lang="en-US" sz="1800" dirty="0" spc="0" kern="0">
+              <a:t> là</a:t>
+            </a:r>
+            <a:r>
+              <a:rPr lang="en-US" sz="1650" dirty="0" spc="0" kern="0">
                 <a:solidFill>
                   <a:srgbClr val="9A98A0"/>
                 </a:solidFill>
@@ -5733,10 +6125,10 @@
                 <a:ea typeface="Be Vietnam Pro" pitchFamily="34" charset="-122"/>
                 <a:cs typeface="Be Vietnam Pro" pitchFamily="34" charset="-120"/>
               </a:rPr>
-              <a:t> họa</a:t>
-            </a:r>
-            <a:r>
-              <a:rPr lang="en-US" sz="1800" dirty="0" spc="-1" kern="0">
+              <a:t> thiết</a:t>
+            </a:r>
+            <a:r>
+              <a:rPr lang="en-US" sz="1650" dirty="0" spc="-20" kern="0">
                 <a:solidFill>
                   <a:srgbClr val="9A98A0"/>
                 </a:solidFill>
@@ -5744,10 +6136,10 @@
                 <a:ea typeface="Be Vietnam Pro" pitchFamily="34" charset="-122"/>
                 <a:cs typeface="Be Vietnam Pro" pitchFamily="34" charset="-120"/>
               </a:rPr>
-              <a:t> là</a:t>
-            </a:r>
-            <a:r>
-              <a:rPr lang="en-US" sz="1800" dirty="0" spc="-5" kern="0">
+              <a:t> kế</a:t>
+            </a:r>
+            <a:r>
+              <a:rPr lang="en-US" sz="1650" dirty="0" spc="0" kern="0">
                 <a:solidFill>
                   <a:srgbClr val="9A98A0"/>
                 </a:solidFill>
@@ -5755,37 +6147,15 @@
                 <a:ea typeface="Be Vietnam Pro" pitchFamily="34" charset="-122"/>
                 <a:cs typeface="Be Vietnam Pro" pitchFamily="34" charset="-120"/>
               </a:rPr>
-              <a:t> thiết</a:t>
-            </a:r>
-            <a:r>
-              <a:rPr lang="en-US" sz="1800" dirty="0" spc="-28" kern="0">
-                <a:solidFill>
-                  <a:srgbClr val="9A98A0"/>
-                </a:solidFill>
-                <a:latin typeface="Be Vietnam Pro" pitchFamily="34" charset="0"/>
-                <a:ea typeface="Be Vietnam Pro" pitchFamily="34" charset="-122"/>
-                <a:cs typeface="Be Vietnam Pro" pitchFamily="34" charset="-120"/>
-              </a:rPr>
-              <a:t> kế</a:t>
-            </a:r>
-            <a:r>
-              <a:rPr lang="en-US" sz="1800" dirty="0" spc="-1" kern="0">
-                <a:solidFill>
-                  <a:srgbClr val="9A98A0"/>
-                </a:solidFill>
-                <a:latin typeface="Be Vietnam Pro" pitchFamily="34" charset="0"/>
-                <a:ea typeface="Be Vietnam Pro" pitchFamily="34" charset="-122"/>
-                <a:cs typeface="Be Vietnam Pro" pitchFamily="34" charset="-120"/>
-              </a:rPr>
               <a:t> mới.</a:t>
             </a:r>
-            <a:endParaRPr lang="en-US" sz="1800" dirty="0"/>
+            <a:endParaRPr lang="en-US" sz="1650" dirty="0"/>
           </a:p>
         </p:txBody>
       </p:sp>
       <p:sp>
         <p:nvSpPr>
-          <p:cNvPr id="39" name="Connector line-1792334895280-40232943"/>
+          <p:cNvPr id="46" name="Connector line-1792388028654-326934642"/>
           <p:cNvSpPr/>
           <p:nvPr/>
         </p:nvSpPr>
@@ -5812,7 +6182,7 @@
       </p:sp>
       <p:sp>
         <p:nvSpPr>
-          <p:cNvPr id="40" name="Shape 38"/>
+          <p:cNvPr id="47" name="Shape 45"/>
           <p:cNvSpPr/>
           <p:nvPr/>
         </p:nvSpPr>
@@ -5832,7 +6202,7 @@
       </p:sp>
       <p:sp>
         <p:nvSpPr>
-          <p:cNvPr id="41" name="Shape 39"/>
+          <p:cNvPr id="48" name="Shape 46"/>
           <p:cNvSpPr/>
           <p:nvPr/>
         </p:nvSpPr>
@@ -5852,7 +6222,7 @@
       </p:sp>
       <p:sp>
         <p:nvSpPr>
-          <p:cNvPr id="42" name="Shape 40"/>
+          <p:cNvPr id="49" name="Shape 47"/>
           <p:cNvSpPr/>
           <p:nvPr/>
         </p:nvSpPr>
@@ -5872,7 +6242,7 @@
       </p:sp>
       <p:sp>
         <p:nvSpPr>
-          <p:cNvPr id="43" name="Shape 41"/>
+          <p:cNvPr id="50" name="Shape 48"/>
           <p:cNvSpPr/>
           <p:nvPr/>
         </p:nvSpPr>
@@ -5892,7 +6262,7 @@
       </p:sp>
       <p:sp>
         <p:nvSpPr>
-          <p:cNvPr id="44" name="Shape 42"/>
+          <p:cNvPr id="51" name="Shape 49"/>
           <p:cNvSpPr/>
           <p:nvPr/>
         </p:nvSpPr>
@@ -5912,7 +6282,7 @@
       </p:sp>
       <p:sp>
         <p:nvSpPr>
-          <p:cNvPr id="45" name="Shape 43"/>
+          <p:cNvPr id="52" name="Shape 50"/>
           <p:cNvSpPr/>
           <p:nvPr/>
         </p:nvSpPr>
@@ -5932,7 +6302,7 @@
       </p:sp>
       <p:sp>
         <p:nvSpPr>
-          <p:cNvPr id="46" name="Shape 44"/>
+          <p:cNvPr id="53" name="Shape 51"/>
           <p:cNvSpPr/>
           <p:nvPr/>
         </p:nvSpPr>
@@ -5952,7 +6322,7 @@
       </p:sp>
       <p:sp>
         <p:nvSpPr>
-          <p:cNvPr id="47" name="Shape 45"/>
+          <p:cNvPr id="54" name="Shape 52"/>
           <p:cNvSpPr/>
           <p:nvPr/>
         </p:nvSpPr>
@@ -5972,7 +6342,7 @@
       </p:sp>
       <p:sp>
         <p:nvSpPr>
-          <p:cNvPr id="48" name="Shape 46"/>
+          <p:cNvPr id="55" name="Shape 53"/>
           <p:cNvSpPr/>
           <p:nvPr/>
         </p:nvSpPr>
@@ -5992,7 +6362,7 @@
       </p:sp>
       <p:sp>
         <p:nvSpPr>
-          <p:cNvPr id="49" name="Shape 47"/>
+          <p:cNvPr id="56" name="Shape 54"/>
           <p:cNvSpPr/>
           <p:nvPr/>
         </p:nvSpPr>
@@ -6012,7 +6382,7 @@
       </p:sp>
       <p:sp>
         <p:nvSpPr>
-          <p:cNvPr id="50" name="Text 48"/>
+          <p:cNvPr id="57" name="Text 55"/>
           <p:cNvSpPr/>
           <p:nvPr/>
         </p:nvSpPr>
@@ -6117,7 +6487,7 @@
       </p:sp>
       <p:sp>
         <p:nvSpPr>
-          <p:cNvPr id="51" name="Shape 49"/>
+          <p:cNvPr id="58" name="Shape 56"/>
           <p:cNvSpPr/>
           <p:nvPr/>
         </p:nvSpPr>
@@ -6141,7 +6511,7 @@
       </p:sp>
       <p:pic>
         <p:nvPicPr>
-          <p:cNvPr id="52" name="Moda image moda-export-watermark-2860b0ed-222f-4d75-b4c6-f54c8ec074e3" descr="">    </p:cNvPr>
+          <p:cNvPr id="59" name="Moda image moda-export-watermark-2860b0ed-222f-4d75-b4c6-f54c8ec074e3" descr="">    </p:cNvPr>
           <p:cNvPicPr>
             <a:picLocks noChangeAspect="1"/>
           </p:cNvPicPr>

</xml_diff>